<commit_message>
updated slide 4 and some minor nits
</commit_message>
<xml_diff>
--- a/126/NMOP/draft-netana-nmop-message-broker-bmp-telemetry-msg-03.pptx
+++ b/126/NMOP/draft-netana-nmop-message-broker-bmp-telemetry-msg-03.pptx
@@ -131,7 +131,7 @@
 <file path=ppt/revisionInfo.xml><?xml version="1.0" encoding="utf-8"?>
 <p1510:revInfo xmlns:a="http://schemas.openxmlformats.org/drawingml/2006/main" xmlns:r="http://schemas.openxmlformats.org/officeDocument/2006/relationships" xmlns:p1510="http://schemas.microsoft.com/office/powerpoint/2015/10/main">
   <p1510:revLst>
-    <p1510:client id="{33AB2929-1981-471E-A8B6-57E934419350}" v="24" dt="2026-07-14T13:24:33.818"/>
+    <p1510:client id="{33AB2929-1981-471E-A8B6-57E934419350}" v="26" dt="2026-07-16T14:28:36.779"/>
   </p1510:revLst>
 </p1510:revInfo>
 </file>
@@ -379,448 +379,6 @@
     </pc:docChg>
   </pc:docChgLst>
   <pc:docChgLst>
-    <pc:chgData name="Graf Thomas, SCS-INI-NET-VNC-E2E" userId="487bc3e3-9ce7-4cdd-b7b4-8899ea88d289" providerId="ADAL" clId="{ADEEF08A-D719-4B50-A383-4105EDA2C206}"/>
-    <pc:docChg chg="undo redo custSel addSld delSld modSld sldOrd">
-      <pc:chgData name="Graf Thomas, SCS-INI-NET-VNC-E2E" userId="487bc3e3-9ce7-4cdd-b7b4-8899ea88d289" providerId="ADAL" clId="{ADEEF08A-D719-4B50-A383-4105EDA2C206}" dt="2026-07-14T13:29:47.977" v="7257" actId="400"/>
-      <pc:docMkLst>
-        <pc:docMk/>
-      </pc:docMkLst>
-      <pc:sldChg chg="modSp mod">
-        <pc:chgData name="Graf Thomas, SCS-INI-NET-VNC-E2E" userId="487bc3e3-9ce7-4cdd-b7b4-8899ea88d289" providerId="ADAL" clId="{ADEEF08A-D719-4B50-A383-4105EDA2C206}" dt="2026-07-14T12:41:35.171" v="6121" actId="20577"/>
-        <pc:sldMkLst>
-          <pc:docMk/>
-          <pc:sldMk cId="3578665336" sldId="1041"/>
-        </pc:sldMkLst>
-        <pc:spChg chg="mod">
-          <ac:chgData name="Graf Thomas, SCS-INI-NET-VNC-E2E" userId="487bc3e3-9ce7-4cdd-b7b4-8899ea88d289" providerId="ADAL" clId="{ADEEF08A-D719-4B50-A383-4105EDA2C206}" dt="2026-07-14T12:41:23.213" v="6114" actId="20577"/>
-          <ac:spMkLst>
-            <pc:docMk/>
-            <pc:sldMk cId="3578665336" sldId="1041"/>
-            <ac:spMk id="5" creationId="{C26208B2-0D10-4C23-B2DE-372A62E98644}"/>
-          </ac:spMkLst>
-        </pc:spChg>
-        <pc:spChg chg="mod">
-          <ac:chgData name="Graf Thomas, SCS-INI-NET-VNC-E2E" userId="487bc3e3-9ce7-4cdd-b7b4-8899ea88d289" providerId="ADAL" clId="{ADEEF08A-D719-4B50-A383-4105EDA2C206}" dt="2026-07-14T12:41:35.171" v="6121" actId="20577"/>
-          <ac:spMkLst>
-            <pc:docMk/>
-            <pc:sldMk cId="3578665336" sldId="1041"/>
-            <ac:spMk id="6" creationId="{6CAA0765-1318-4A03-8F91-D3ECC43D8FA7}"/>
-          </ac:spMkLst>
-        </pc:spChg>
-      </pc:sldChg>
-      <pc:sldChg chg="modSp del mod">
-        <pc:chgData name="Graf Thomas, SCS-INI-NET-VNC-E2E" userId="487bc3e3-9ce7-4cdd-b7b4-8899ea88d289" providerId="ADAL" clId="{ADEEF08A-D719-4B50-A383-4105EDA2C206}" dt="2026-07-14T12:55:18.417" v="6196" actId="47"/>
-        <pc:sldMkLst>
-          <pc:docMk/>
-          <pc:sldMk cId="1088069469" sldId="26422"/>
-        </pc:sldMkLst>
-      </pc:sldChg>
-      <pc:sldChg chg="addSp modSp mod">
-        <pc:chgData name="Graf Thomas, SCS-INI-NET-VNC-E2E" userId="487bc3e3-9ce7-4cdd-b7b4-8899ea88d289" providerId="ADAL" clId="{ADEEF08A-D719-4B50-A383-4105EDA2C206}" dt="2026-03-06T15:14:32.681" v="6011" actId="14100"/>
-        <pc:sldMkLst>
-          <pc:docMk/>
-          <pc:sldMk cId="670772560" sldId="2145706220"/>
-        </pc:sldMkLst>
-      </pc:sldChg>
-      <pc:sldChg chg="delSp modSp add mod">
-        <pc:chgData name="Graf Thomas, SCS-INI-NET-VNC-E2E" userId="487bc3e3-9ce7-4cdd-b7b4-8899ea88d289" providerId="ADAL" clId="{ADEEF08A-D719-4B50-A383-4105EDA2C206}" dt="2026-07-14T12:41:55.778" v="6133"/>
-        <pc:sldMkLst>
-          <pc:docMk/>
-          <pc:sldMk cId="2750719351" sldId="2145706243"/>
-        </pc:sldMkLst>
-        <pc:spChg chg="mod">
-          <ac:chgData name="Graf Thomas, SCS-INI-NET-VNC-E2E" userId="487bc3e3-9ce7-4cdd-b7b4-8899ea88d289" providerId="ADAL" clId="{ADEEF08A-D719-4B50-A383-4105EDA2C206}" dt="2026-07-14T12:41:55.778" v="6133"/>
-          <ac:spMkLst>
-            <pc:docMk/>
-            <pc:sldMk cId="2750719351" sldId="2145706243"/>
-            <ac:spMk id="3" creationId="{E1C8AC62-B5C5-ADE4-1957-88D3A14E964A}"/>
-          </ac:spMkLst>
-        </pc:spChg>
-      </pc:sldChg>
-      <pc:sldChg chg="addSp delSp modSp del mod">
-        <pc:chgData name="Graf Thomas, SCS-INI-NET-VNC-E2E" userId="487bc3e3-9ce7-4cdd-b7b4-8899ea88d289" providerId="ADAL" clId="{ADEEF08A-D719-4B50-A383-4105EDA2C206}" dt="2026-07-14T12:55:56.511" v="6197" actId="47"/>
-        <pc:sldMkLst>
-          <pc:docMk/>
-          <pc:sldMk cId="1315775908" sldId="2145706280"/>
-        </pc:sldMkLst>
-      </pc:sldChg>
-      <pc:sldChg chg="addSp delSp modSp del mod">
-        <pc:chgData name="Graf Thomas, SCS-INI-NET-VNC-E2E" userId="487bc3e3-9ce7-4cdd-b7b4-8899ea88d289" providerId="ADAL" clId="{ADEEF08A-D719-4B50-A383-4105EDA2C206}" dt="2026-07-14T12:55:56.511" v="6197" actId="47"/>
-        <pc:sldMkLst>
-          <pc:docMk/>
-          <pc:sldMk cId="3685482022" sldId="2145706295"/>
-        </pc:sldMkLst>
-        <pc:spChg chg="mod">
-          <ac:chgData name="Graf Thomas, SCS-INI-NET-VNC-E2E" userId="487bc3e3-9ce7-4cdd-b7b4-8899ea88d289" providerId="ADAL" clId="{ADEEF08A-D719-4B50-A383-4105EDA2C206}" dt="2026-07-14T12:48:43.491" v="6138" actId="1076"/>
-          <ac:spMkLst>
-            <pc:docMk/>
-            <pc:sldMk cId="3685482022" sldId="2145706295"/>
-            <ac:spMk id="9" creationId="{B59BD151-8C28-BD0B-5959-748ED326249A}"/>
-          </ac:spMkLst>
-        </pc:spChg>
-      </pc:sldChg>
-      <pc:sldChg chg="addSp delSp modSp del mod">
-        <pc:chgData name="Graf Thomas, SCS-INI-NET-VNC-E2E" userId="487bc3e3-9ce7-4cdd-b7b4-8899ea88d289" providerId="ADAL" clId="{ADEEF08A-D719-4B50-A383-4105EDA2C206}" dt="2026-07-14T12:56:53.974" v="6205" actId="47"/>
-        <pc:sldMkLst>
-          <pc:docMk/>
-          <pc:sldMk cId="1475201924" sldId="2145706296"/>
-        </pc:sldMkLst>
-        <pc:picChg chg="mod">
-          <ac:chgData name="Graf Thomas, SCS-INI-NET-VNC-E2E" userId="487bc3e3-9ce7-4cdd-b7b4-8899ea88d289" providerId="ADAL" clId="{ADEEF08A-D719-4B50-A383-4105EDA2C206}" dt="2026-07-14T12:49:12.783" v="6139" actId="14826"/>
-          <ac:picMkLst>
-            <pc:docMk/>
-            <pc:sldMk cId="1475201924" sldId="2145706296"/>
-            <ac:picMk id="3" creationId="{7FE1D9BE-38E0-66CE-DDC0-29019F670C04}"/>
-          </ac:picMkLst>
-        </pc:picChg>
-      </pc:sldChg>
-      <pc:sldChg chg="addSp delSp modSp del mod">
-        <pc:chgData name="Graf Thomas, SCS-INI-NET-VNC-E2E" userId="487bc3e3-9ce7-4cdd-b7b4-8899ea88d289" providerId="ADAL" clId="{ADEEF08A-D719-4B50-A383-4105EDA2C206}" dt="2026-07-14T12:56:44.698" v="6204" actId="47"/>
-        <pc:sldMkLst>
-          <pc:docMk/>
-          <pc:sldMk cId="710783608" sldId="2145706297"/>
-        </pc:sldMkLst>
-        <pc:spChg chg="mod">
-          <ac:chgData name="Graf Thomas, SCS-INI-NET-VNC-E2E" userId="487bc3e3-9ce7-4cdd-b7b4-8899ea88d289" providerId="ADAL" clId="{ADEEF08A-D719-4B50-A383-4105EDA2C206}" dt="2026-07-14T12:51:15.075" v="6146" actId="14100"/>
-          <ac:spMkLst>
-            <pc:docMk/>
-            <pc:sldMk cId="710783608" sldId="2145706297"/>
-            <ac:spMk id="5" creationId="{749FD0AD-E617-98E7-0E99-692C31C4B242}"/>
-          </ac:spMkLst>
-        </pc:spChg>
-        <pc:picChg chg="add mod">
-          <ac:chgData name="Graf Thomas, SCS-INI-NET-VNC-E2E" userId="487bc3e3-9ce7-4cdd-b7b4-8899ea88d289" providerId="ADAL" clId="{ADEEF08A-D719-4B50-A383-4105EDA2C206}" dt="2026-07-14T12:50:35.309" v="6144" actId="1076"/>
-          <ac:picMkLst>
-            <pc:docMk/>
-            <pc:sldMk cId="710783608" sldId="2145706297"/>
-            <ac:picMk id="3" creationId="{883A53C0-0E1E-9DCE-9996-F8C9123C6621}"/>
-          </ac:picMkLst>
-        </pc:picChg>
-        <pc:picChg chg="del mod">
-          <ac:chgData name="Graf Thomas, SCS-INI-NET-VNC-E2E" userId="487bc3e3-9ce7-4cdd-b7b4-8899ea88d289" providerId="ADAL" clId="{ADEEF08A-D719-4B50-A383-4105EDA2C206}" dt="2026-07-14T12:50:27.664" v="6142" actId="478"/>
-          <ac:picMkLst>
-            <pc:docMk/>
-            <pc:sldMk cId="710783608" sldId="2145706297"/>
-            <ac:picMk id="4" creationId="{428EBA8D-181B-508E-90C7-3CCEC074640A}"/>
-          </ac:picMkLst>
-        </pc:picChg>
-      </pc:sldChg>
-      <pc:sldChg chg="addSp delSp modSp mod ord">
-        <pc:chgData name="Graf Thomas, SCS-INI-NET-VNC-E2E" userId="487bc3e3-9ce7-4cdd-b7b4-8899ea88d289" providerId="ADAL" clId="{ADEEF08A-D719-4B50-A383-4105EDA2C206}" dt="2026-07-14T12:56:59.627" v="6207"/>
-        <pc:sldMkLst>
-          <pc:docMk/>
-          <pc:sldMk cId="3625312977" sldId="2145706298"/>
-        </pc:sldMkLst>
-        <pc:picChg chg="add mod">
-          <ac:chgData name="Graf Thomas, SCS-INI-NET-VNC-E2E" userId="487bc3e3-9ce7-4cdd-b7b4-8899ea88d289" providerId="ADAL" clId="{ADEEF08A-D719-4B50-A383-4105EDA2C206}" dt="2026-07-14T12:56:39.058" v="6203" actId="1076"/>
-          <ac:picMkLst>
-            <pc:docMk/>
-            <pc:sldMk cId="3625312977" sldId="2145706298"/>
-            <ac:picMk id="3" creationId="{3D20887A-63D9-A4B9-AA81-58DA821129FA}"/>
-          </ac:picMkLst>
-        </pc:picChg>
-        <pc:picChg chg="del">
-          <ac:chgData name="Graf Thomas, SCS-INI-NET-VNC-E2E" userId="487bc3e3-9ce7-4cdd-b7b4-8899ea88d289" providerId="ADAL" clId="{ADEEF08A-D719-4B50-A383-4105EDA2C206}" dt="2026-07-14T12:56:26.908" v="6198" actId="478"/>
-          <ac:picMkLst>
-            <pc:docMk/>
-            <pc:sldMk cId="3625312977" sldId="2145706298"/>
-            <ac:picMk id="4" creationId="{5B845DB1-AD33-F165-0A69-794539AA8954}"/>
-          </ac:picMkLst>
-        </pc:picChg>
-      </pc:sldChg>
-      <pc:sldChg chg="del">
-        <pc:chgData name="Graf Thomas, SCS-INI-NET-VNC-E2E" userId="487bc3e3-9ce7-4cdd-b7b4-8899ea88d289" providerId="ADAL" clId="{ADEEF08A-D719-4B50-A383-4105EDA2C206}" dt="2026-03-06T12:57:35.600" v="1725" actId="47"/>
-        <pc:sldMkLst>
-          <pc:docMk/>
-          <pc:sldMk cId="2117458142" sldId="2145706299"/>
-        </pc:sldMkLst>
-      </pc:sldChg>
-      <pc:sldChg chg="del">
-        <pc:chgData name="Graf Thomas, SCS-INI-NET-VNC-E2E" userId="487bc3e3-9ce7-4cdd-b7b4-8899ea88d289" providerId="ADAL" clId="{ADEEF08A-D719-4B50-A383-4105EDA2C206}" dt="2026-07-14T12:55:18.417" v="6196" actId="47"/>
-        <pc:sldMkLst>
-          <pc:docMk/>
-          <pc:sldMk cId="1230411846" sldId="2145706300"/>
-        </pc:sldMkLst>
-      </pc:sldChg>
-      <pc:sldChg chg="modSp del mod">
-        <pc:chgData name="Graf Thomas, SCS-INI-NET-VNC-E2E" userId="487bc3e3-9ce7-4cdd-b7b4-8899ea88d289" providerId="ADAL" clId="{ADEEF08A-D719-4B50-A383-4105EDA2C206}" dt="2026-07-14T12:55:18.417" v="6196" actId="47"/>
-        <pc:sldMkLst>
-          <pc:docMk/>
-          <pc:sldMk cId="4162477740" sldId="2145706301"/>
-        </pc:sldMkLst>
-      </pc:sldChg>
-      <pc:sldChg chg="modSp mod ord">
-        <pc:chgData name="Graf Thomas, SCS-INI-NET-VNC-E2E" userId="487bc3e3-9ce7-4cdd-b7b4-8899ea88d289" providerId="ADAL" clId="{ADEEF08A-D719-4B50-A383-4105EDA2C206}" dt="2026-07-14T13:29:47.977" v="7257" actId="400"/>
-        <pc:sldMkLst>
-          <pc:docMk/>
-          <pc:sldMk cId="1190312228" sldId="2145706302"/>
-        </pc:sldMkLst>
-        <pc:spChg chg="mod">
-          <ac:chgData name="Graf Thomas, SCS-INI-NET-VNC-E2E" userId="487bc3e3-9ce7-4cdd-b7b4-8899ea88d289" providerId="ADAL" clId="{ADEEF08A-D719-4B50-A383-4105EDA2C206}" dt="2026-07-14T13:29:47.977" v="7257" actId="400"/>
-          <ac:spMkLst>
-            <pc:docMk/>
-            <pc:sldMk cId="1190312228" sldId="2145706302"/>
-            <ac:spMk id="3" creationId="{16030435-8548-CFD7-E67B-E4D3DD29D75F}"/>
-          </ac:spMkLst>
-        </pc:spChg>
-      </pc:sldChg>
-      <pc:sldChg chg="addSp modSp mod ord">
-        <pc:chgData name="Graf Thomas, SCS-INI-NET-VNC-E2E" userId="487bc3e3-9ce7-4cdd-b7b4-8899ea88d289" providerId="ADAL" clId="{ADEEF08A-D719-4B50-A383-4105EDA2C206}" dt="2026-07-14T13:14:24.593" v="6603" actId="13926"/>
-        <pc:sldMkLst>
-          <pc:docMk/>
-          <pc:sldMk cId="4251917088" sldId="2145706303"/>
-        </pc:sldMkLst>
-        <pc:spChg chg="mod">
-          <ac:chgData name="Graf Thomas, SCS-INI-NET-VNC-E2E" userId="487bc3e3-9ce7-4cdd-b7b4-8899ea88d289" providerId="ADAL" clId="{ADEEF08A-D719-4B50-A383-4105EDA2C206}" dt="2026-07-14T13:14:03.698" v="6600" actId="20577"/>
-          <ac:spMkLst>
-            <pc:docMk/>
-            <pc:sldMk cId="4251917088" sldId="2145706303"/>
-            <ac:spMk id="2" creationId="{9D734BEF-C196-3BAF-0F2E-FB66BF042884}"/>
-          </ac:spMkLst>
-        </pc:spChg>
-        <pc:spChg chg="mod">
-          <ac:chgData name="Graf Thomas, SCS-INI-NET-VNC-E2E" userId="487bc3e3-9ce7-4cdd-b7b4-8899ea88d289" providerId="ADAL" clId="{ADEEF08A-D719-4B50-A383-4105EDA2C206}" dt="2026-07-14T13:06:13.034" v="6332" actId="20577"/>
-          <ac:spMkLst>
-            <pc:docMk/>
-            <pc:sldMk cId="4251917088" sldId="2145706303"/>
-            <ac:spMk id="3" creationId="{6EA985DA-ABCF-AB10-5C45-1B7050950E17}"/>
-          </ac:spMkLst>
-        </pc:spChg>
-        <pc:spChg chg="add mod">
-          <ac:chgData name="Graf Thomas, SCS-INI-NET-VNC-E2E" userId="487bc3e3-9ce7-4cdd-b7b4-8899ea88d289" providerId="ADAL" clId="{ADEEF08A-D719-4B50-A383-4105EDA2C206}" dt="2026-07-14T13:14:24.593" v="6603" actId="13926"/>
-          <ac:spMkLst>
-            <pc:docMk/>
-            <pc:sldMk cId="4251917088" sldId="2145706303"/>
-            <ac:spMk id="5" creationId="{9656C51F-D666-FF4B-6E06-11C9E3E8A8A2}"/>
-          </ac:spMkLst>
-        </pc:spChg>
-      </pc:sldChg>
-      <pc:sldChg chg="modSp del mod">
-        <pc:chgData name="Graf Thomas, SCS-INI-NET-VNC-E2E" userId="487bc3e3-9ce7-4cdd-b7b4-8899ea88d289" providerId="ADAL" clId="{ADEEF08A-D719-4B50-A383-4105EDA2C206}" dt="2026-07-14T12:57:44.073" v="6210" actId="47"/>
-        <pc:sldMkLst>
-          <pc:docMk/>
-          <pc:sldMk cId="2204044421" sldId="2145706304"/>
-        </pc:sldMkLst>
-      </pc:sldChg>
-      <pc:sldChg chg="modSp del mod ord">
-        <pc:chgData name="Graf Thomas, SCS-INI-NET-VNC-E2E" userId="487bc3e3-9ce7-4cdd-b7b4-8899ea88d289" providerId="ADAL" clId="{ADEEF08A-D719-4B50-A383-4105EDA2C206}" dt="2026-07-14T13:25:45.052" v="6971" actId="47"/>
-        <pc:sldMkLst>
-          <pc:docMk/>
-          <pc:sldMk cId="3686017286" sldId="2145706305"/>
-        </pc:sldMkLst>
-      </pc:sldChg>
-      <pc:sldChg chg="delSp modSp mod">
-        <pc:chgData name="Graf Thomas, SCS-INI-NET-VNC-E2E" userId="487bc3e3-9ce7-4cdd-b7b4-8899ea88d289" providerId="ADAL" clId="{ADEEF08A-D719-4B50-A383-4105EDA2C206}" dt="2026-07-14T13:27:26.795" v="7186" actId="20577"/>
-        <pc:sldMkLst>
-          <pc:docMk/>
-          <pc:sldMk cId="3305081943" sldId="2145706306"/>
-        </pc:sldMkLst>
-        <pc:spChg chg="mod">
-          <ac:chgData name="Graf Thomas, SCS-INI-NET-VNC-E2E" userId="487bc3e3-9ce7-4cdd-b7b4-8899ea88d289" providerId="ADAL" clId="{ADEEF08A-D719-4B50-A383-4105EDA2C206}" dt="2026-07-14T13:25:50.342" v="6972" actId="20577"/>
-          <ac:spMkLst>
-            <pc:docMk/>
-            <pc:sldMk cId="3305081943" sldId="2145706306"/>
-            <ac:spMk id="2" creationId="{B37520E1-A4E0-F3CA-29AD-D2D9ADADBEF0}"/>
-          </ac:spMkLst>
-        </pc:spChg>
-        <pc:spChg chg="mod">
-          <ac:chgData name="Graf Thomas, SCS-INI-NET-VNC-E2E" userId="487bc3e3-9ce7-4cdd-b7b4-8899ea88d289" providerId="ADAL" clId="{ADEEF08A-D719-4B50-A383-4105EDA2C206}" dt="2026-07-14T13:27:26.795" v="7186" actId="20577"/>
-          <ac:spMkLst>
-            <pc:docMk/>
-            <pc:sldMk cId="3305081943" sldId="2145706306"/>
-            <ac:spMk id="3" creationId="{3EA36F6F-A76C-ACD7-BA9E-6565DCCE91FE}"/>
-          </ac:spMkLst>
-        </pc:spChg>
-      </pc:sldChg>
-      <pc:sldChg chg="addSp delSp modSp add del mod">
-        <pc:chgData name="Graf Thomas, SCS-INI-NET-VNC-E2E" userId="487bc3e3-9ce7-4cdd-b7b4-8899ea88d289" providerId="ADAL" clId="{ADEEF08A-D719-4B50-A383-4105EDA2C206}" dt="2026-07-14T12:55:18.417" v="6196" actId="47"/>
-        <pc:sldMkLst>
-          <pc:docMk/>
-          <pc:sldMk cId="2590364080" sldId="2145706307"/>
-        </pc:sldMkLst>
-      </pc:sldChg>
-      <pc:sldChg chg="addSp delSp modSp add del mod">
-        <pc:chgData name="Graf Thomas, SCS-INI-NET-VNC-E2E" userId="487bc3e3-9ce7-4cdd-b7b4-8899ea88d289" providerId="ADAL" clId="{ADEEF08A-D719-4B50-A383-4105EDA2C206}" dt="2026-07-14T12:55:18.417" v="6196" actId="47"/>
-        <pc:sldMkLst>
-          <pc:docMk/>
-          <pc:sldMk cId="1296954665" sldId="2145706308"/>
-        </pc:sldMkLst>
-      </pc:sldChg>
-      <pc:sldChg chg="addSp delSp modSp add del mod">
-        <pc:chgData name="Graf Thomas, SCS-INI-NET-VNC-E2E" userId="487bc3e3-9ce7-4cdd-b7b4-8899ea88d289" providerId="ADAL" clId="{ADEEF08A-D719-4B50-A383-4105EDA2C206}" dt="2026-07-14T13:29:15.698" v="7256" actId="20577"/>
-        <pc:sldMkLst>
-          <pc:docMk/>
-          <pc:sldMk cId="2961389282" sldId="2145706309"/>
-        </pc:sldMkLst>
-        <pc:spChg chg="mod">
-          <ac:chgData name="Graf Thomas, SCS-INI-NET-VNC-E2E" userId="487bc3e3-9ce7-4cdd-b7b4-8899ea88d289" providerId="ADAL" clId="{ADEEF08A-D719-4B50-A383-4105EDA2C206}" dt="2026-07-14T13:29:15.698" v="7256" actId="20577"/>
-          <ac:spMkLst>
-            <pc:docMk/>
-            <pc:sldMk cId="2961389282" sldId="2145706309"/>
-            <ac:spMk id="3" creationId="{3F4CBE7F-1450-A754-E524-9EE662BEDE60}"/>
-          </ac:spMkLst>
-        </pc:spChg>
-      </pc:sldChg>
-      <pc:sldChg chg="modSp add del mod">
-        <pc:chgData name="Graf Thomas, SCS-INI-NET-VNC-E2E" userId="487bc3e3-9ce7-4cdd-b7b4-8899ea88d289" providerId="ADAL" clId="{ADEEF08A-D719-4B50-A383-4105EDA2C206}" dt="2026-07-14T12:54:53.444" v="6195" actId="47"/>
-        <pc:sldMkLst>
-          <pc:docMk/>
-          <pc:sldMk cId="3526121720" sldId="2145706310"/>
-        </pc:sldMkLst>
-      </pc:sldChg>
-      <pc:sldChg chg="modSp add mod">
-        <pc:chgData name="Graf Thomas, SCS-INI-NET-VNC-E2E" userId="487bc3e3-9ce7-4cdd-b7b4-8899ea88d289" providerId="ADAL" clId="{ADEEF08A-D719-4B50-A383-4105EDA2C206}" dt="2026-07-14T13:24:39.640" v="6968" actId="20577"/>
-        <pc:sldMkLst>
-          <pc:docMk/>
-          <pc:sldMk cId="4128600093" sldId="2145706310"/>
-        </pc:sldMkLst>
-        <pc:spChg chg="mod">
-          <ac:chgData name="Graf Thomas, SCS-INI-NET-VNC-E2E" userId="487bc3e3-9ce7-4cdd-b7b4-8899ea88d289" providerId="ADAL" clId="{ADEEF08A-D719-4B50-A383-4105EDA2C206}" dt="2026-07-14T13:24:39.640" v="6968" actId="20577"/>
-          <ac:spMkLst>
-            <pc:docMk/>
-            <pc:sldMk cId="4128600093" sldId="2145706310"/>
-            <ac:spMk id="3" creationId="{CB0EE0D0-E2FC-EC67-C3D8-B007AACC1C77}"/>
-          </ac:spMkLst>
-        </pc:spChg>
-      </pc:sldChg>
-      <pc:sldChg chg="add del">
-        <pc:chgData name="Graf Thomas, SCS-INI-NET-VNC-E2E" userId="487bc3e3-9ce7-4cdd-b7b4-8899ea88d289" providerId="ADAL" clId="{ADEEF08A-D719-4B50-A383-4105EDA2C206}" dt="2026-07-14T12:42:45.033" v="6134" actId="47"/>
-        <pc:sldMkLst>
-          <pc:docMk/>
-          <pc:sldMk cId="1403244520" sldId="2145706311"/>
-        </pc:sldMkLst>
-      </pc:sldChg>
-      <pc:sldChg chg="modSp add mod">
-        <pc:chgData name="Graf Thomas, SCS-INI-NET-VNC-E2E" userId="487bc3e3-9ce7-4cdd-b7b4-8899ea88d289" providerId="ADAL" clId="{ADEEF08A-D719-4B50-A383-4105EDA2C206}" dt="2026-07-14T13:23:36.982" v="6930" actId="1076"/>
-        <pc:sldMkLst>
-          <pc:docMk/>
-          <pc:sldMk cId="2687771710" sldId="2145706311"/>
-        </pc:sldMkLst>
-        <pc:spChg chg="mod">
-          <ac:chgData name="Graf Thomas, SCS-INI-NET-VNC-E2E" userId="487bc3e3-9ce7-4cdd-b7b4-8899ea88d289" providerId="ADAL" clId="{ADEEF08A-D719-4B50-A383-4105EDA2C206}" dt="2026-07-14T13:22:33.586" v="6903" actId="5793"/>
-          <ac:spMkLst>
-            <pc:docMk/>
-            <pc:sldMk cId="2687771710" sldId="2145706311"/>
-            <ac:spMk id="2" creationId="{AB2DDFA9-710A-5629-89B2-FB87E211CD78}"/>
-          </ac:spMkLst>
-        </pc:spChg>
-        <pc:spChg chg="mod">
-          <ac:chgData name="Graf Thomas, SCS-INI-NET-VNC-E2E" userId="487bc3e3-9ce7-4cdd-b7b4-8899ea88d289" providerId="ADAL" clId="{ADEEF08A-D719-4B50-A383-4105EDA2C206}" dt="2026-07-14T13:22:55.594" v="6923" actId="20577"/>
-          <ac:spMkLst>
-            <pc:docMk/>
-            <pc:sldMk cId="2687771710" sldId="2145706311"/>
-            <ac:spMk id="3" creationId="{421E468E-B525-66BD-FBA4-8EB776CE47B6}"/>
-          </ac:spMkLst>
-        </pc:spChg>
-        <pc:spChg chg="mod">
-          <ac:chgData name="Graf Thomas, SCS-INI-NET-VNC-E2E" userId="487bc3e3-9ce7-4cdd-b7b4-8899ea88d289" providerId="ADAL" clId="{ADEEF08A-D719-4B50-A383-4105EDA2C206}" dt="2026-07-14T13:23:36.982" v="6930" actId="1076"/>
-          <ac:spMkLst>
-            <pc:docMk/>
-            <pc:sldMk cId="2687771710" sldId="2145706311"/>
-            <ac:spMk id="5" creationId="{2D333956-C5AE-D528-B067-D9A012810329}"/>
-          </ac:spMkLst>
-        </pc:spChg>
-      </pc:sldChg>
-      <pc:sldChg chg="add del">
-        <pc:chgData name="Graf Thomas, SCS-INI-NET-VNC-E2E" userId="487bc3e3-9ce7-4cdd-b7b4-8899ea88d289" providerId="ADAL" clId="{ADEEF08A-D719-4B50-A383-4105EDA2C206}" dt="2026-07-14T12:42:45.033" v="6134" actId="47"/>
-        <pc:sldMkLst>
-          <pc:docMk/>
-          <pc:sldMk cId="632967186" sldId="2145706312"/>
-        </pc:sldMkLst>
-      </pc:sldChg>
-      <pc:sldChg chg="modSp add mod">
-        <pc:chgData name="Graf Thomas, SCS-INI-NET-VNC-E2E" userId="487bc3e3-9ce7-4cdd-b7b4-8899ea88d289" providerId="ADAL" clId="{ADEEF08A-D719-4B50-A383-4105EDA2C206}" dt="2026-07-14T13:23:50.593" v="6938" actId="20577"/>
-        <pc:sldMkLst>
-          <pc:docMk/>
-          <pc:sldMk cId="3807185294" sldId="2145706312"/>
-        </pc:sldMkLst>
-        <pc:spChg chg="mod">
-          <ac:chgData name="Graf Thomas, SCS-INI-NET-VNC-E2E" userId="487bc3e3-9ce7-4cdd-b7b4-8899ea88d289" providerId="ADAL" clId="{ADEEF08A-D719-4B50-A383-4105EDA2C206}" dt="2026-07-14T13:23:50.593" v="6938" actId="20577"/>
-          <ac:spMkLst>
-            <pc:docMk/>
-            <pc:sldMk cId="3807185294" sldId="2145706312"/>
-            <ac:spMk id="2" creationId="{5B8888DB-A90D-A25F-9FAA-CB0DFB34C2A9}"/>
-          </ac:spMkLst>
-        </pc:spChg>
-        <pc:spChg chg="mod">
-          <ac:chgData name="Graf Thomas, SCS-INI-NET-VNC-E2E" userId="487bc3e3-9ce7-4cdd-b7b4-8899ea88d289" providerId="ADAL" clId="{ADEEF08A-D719-4B50-A383-4105EDA2C206}" dt="2026-07-14T13:18:52.189" v="6783" actId="20577"/>
-          <ac:spMkLst>
-            <pc:docMk/>
-            <pc:sldMk cId="3807185294" sldId="2145706312"/>
-            <ac:spMk id="3" creationId="{D1A52B7B-3570-1B5D-1F67-9B38890F5748}"/>
-          </ac:spMkLst>
-        </pc:spChg>
-        <pc:spChg chg="mod">
-          <ac:chgData name="Graf Thomas, SCS-INI-NET-VNC-E2E" userId="487bc3e3-9ce7-4cdd-b7b4-8899ea88d289" providerId="ADAL" clId="{ADEEF08A-D719-4B50-A383-4105EDA2C206}" dt="2026-07-14T13:21:02.081" v="6809" actId="13926"/>
-          <ac:spMkLst>
-            <pc:docMk/>
-            <pc:sldMk cId="3807185294" sldId="2145706312"/>
-            <ac:spMk id="5" creationId="{ACF3B6D0-4561-839A-14B8-04636B057F64}"/>
-          </ac:spMkLst>
-        </pc:spChg>
-      </pc:sldChg>
-      <pc:sldChg chg="modSp add mod ord">
-        <pc:chgData name="Graf Thomas, SCS-INI-NET-VNC-E2E" userId="487bc3e3-9ce7-4cdd-b7b4-8899ea88d289" providerId="ADAL" clId="{ADEEF08A-D719-4B50-A383-4105EDA2C206}" dt="2026-07-14T13:22:20.653" v="6862"/>
-        <pc:sldMkLst>
-          <pc:docMk/>
-          <pc:sldMk cId="1452467401" sldId="2145706313"/>
-        </pc:sldMkLst>
-        <pc:spChg chg="mod">
-          <ac:chgData name="Graf Thomas, SCS-INI-NET-VNC-E2E" userId="487bc3e3-9ce7-4cdd-b7b4-8899ea88d289" providerId="ADAL" clId="{ADEEF08A-D719-4B50-A383-4105EDA2C206}" dt="2026-07-14T13:21:32.190" v="6845" actId="20577"/>
-          <ac:spMkLst>
-            <pc:docMk/>
-            <pc:sldMk cId="1452467401" sldId="2145706313"/>
-            <ac:spMk id="2" creationId="{8DE65009-4589-3EEA-F6BA-6387E69395C3}"/>
-          </ac:spMkLst>
-        </pc:spChg>
-        <pc:spChg chg="mod">
-          <ac:chgData name="Graf Thomas, SCS-INI-NET-VNC-E2E" userId="487bc3e3-9ce7-4cdd-b7b4-8899ea88d289" providerId="ADAL" clId="{ADEEF08A-D719-4B50-A383-4105EDA2C206}" dt="2026-07-14T13:21:37.895" v="6847" actId="20577"/>
-          <ac:spMkLst>
-            <pc:docMk/>
-            <pc:sldMk cId="1452467401" sldId="2145706313"/>
-            <ac:spMk id="3" creationId="{BC3C6DC3-F83A-8266-9A3C-EC72FFB72F03}"/>
-          </ac:spMkLst>
-        </pc:spChg>
-        <pc:spChg chg="mod">
-          <ac:chgData name="Graf Thomas, SCS-INI-NET-VNC-E2E" userId="487bc3e3-9ce7-4cdd-b7b4-8899ea88d289" providerId="ADAL" clId="{ADEEF08A-D719-4B50-A383-4105EDA2C206}" dt="2026-07-14T13:22:09.634" v="6860" actId="1076"/>
-          <ac:spMkLst>
-            <pc:docMk/>
-            <pc:sldMk cId="1452467401" sldId="2145706313"/>
-            <ac:spMk id="5" creationId="{7B8D7887-C93D-FC29-FE8D-AB3A78A80370}"/>
-          </ac:spMkLst>
-        </pc:spChg>
-      </pc:sldChg>
-      <pc:sldChg chg="add del">
-        <pc:chgData name="Graf Thomas, SCS-INI-NET-VNC-E2E" userId="487bc3e3-9ce7-4cdd-b7b4-8899ea88d289" providerId="ADAL" clId="{ADEEF08A-D719-4B50-A383-4105EDA2C206}" dt="2026-07-14T12:42:45.033" v="6134" actId="47"/>
-        <pc:sldMkLst>
-          <pc:docMk/>
-          <pc:sldMk cId="3870071406" sldId="2145706313"/>
-        </pc:sldMkLst>
-      </pc:sldChg>
-      <pc:sldChg chg="add del">
-        <pc:chgData name="Graf Thomas, SCS-INI-NET-VNC-E2E" userId="487bc3e3-9ce7-4cdd-b7b4-8899ea88d289" providerId="ADAL" clId="{ADEEF08A-D719-4B50-A383-4105EDA2C206}" dt="2026-07-14T12:42:45.033" v="6134" actId="47"/>
-        <pc:sldMkLst>
-          <pc:docMk/>
-          <pc:sldMk cId="2884885474" sldId="2145706314"/>
-        </pc:sldMkLst>
-      </pc:sldChg>
-      <pc:sldChg chg="modSp add del mod">
-        <pc:chgData name="Graf Thomas, SCS-INI-NET-VNC-E2E" userId="487bc3e3-9ce7-4cdd-b7b4-8899ea88d289" providerId="ADAL" clId="{ADEEF08A-D719-4B50-A383-4105EDA2C206}" dt="2026-07-14T12:42:45.033" v="6134" actId="47"/>
-        <pc:sldMkLst>
-          <pc:docMk/>
-          <pc:sldMk cId="822671291" sldId="2145706315"/>
-        </pc:sldMkLst>
-      </pc:sldChg>
-      <pc:sldChg chg="modSp add del mod">
-        <pc:chgData name="Graf Thomas, SCS-INI-NET-VNC-E2E" userId="487bc3e3-9ce7-4cdd-b7b4-8899ea88d289" providerId="ADAL" clId="{ADEEF08A-D719-4B50-A383-4105EDA2C206}" dt="2026-03-06T15:27:05.528" v="6106" actId="47"/>
-        <pc:sldMkLst>
-          <pc:docMk/>
-          <pc:sldMk cId="3812470375" sldId="2145706316"/>
-        </pc:sldMkLst>
-      </pc:sldChg>
-    </pc:docChg>
-  </pc:docChgLst>
-  <pc:docChgLst>
     <pc:chgData name="Graf Thomas, SCS-INI-NET-VNC-E2E" userId="487bc3e3-9ce7-4cdd-b7b4-8899ea88d289" providerId="ADAL" clId="{54A39940-08FA-4A7E-9BB9-600FEA25ABAF}"/>
     <pc:docChg chg="undo redo custSel addSld delSld modSld sldOrd">
       <pc:chgData name="Graf Thomas, SCS-INI-NET-VNC-E2E" userId="487bc3e3-9ce7-4cdd-b7b4-8899ea88d289" providerId="ADAL" clId="{54A39940-08FA-4A7E-9BB9-600FEA25ABAF}" dt="2025-10-26T13:07:06.475" v="9735" actId="14100"/>
@@ -1042,6 +600,438 @@
         <pc:sldMkLst>
           <pc:docMk/>
           <pc:sldMk cId="3305081943" sldId="2145706306"/>
+        </pc:sldMkLst>
+      </pc:sldChg>
+    </pc:docChg>
+  </pc:docChgLst>
+  <pc:docChgLst>
+    <pc:chgData name="Graf Thomas, SCS-INI-NET-VNC-E2E" userId="487bc3e3-9ce7-4cdd-b7b4-8899ea88d289" providerId="ADAL" clId="{ADEEF08A-D719-4B50-A383-4105EDA2C206}"/>
+    <pc:docChg chg="undo redo custSel addSld delSld modSld sldOrd">
+      <pc:chgData name="Graf Thomas, SCS-INI-NET-VNC-E2E" userId="487bc3e3-9ce7-4cdd-b7b4-8899ea88d289" providerId="ADAL" clId="{ADEEF08A-D719-4B50-A383-4105EDA2C206}" dt="2026-07-16T14:31:16.073" v="7504" actId="20577"/>
+      <pc:docMkLst>
+        <pc:docMk/>
+      </pc:docMkLst>
+      <pc:sldChg chg="modSp mod">
+        <pc:chgData name="Graf Thomas, SCS-INI-NET-VNC-E2E" userId="487bc3e3-9ce7-4cdd-b7b4-8899ea88d289" providerId="ADAL" clId="{ADEEF08A-D719-4B50-A383-4105EDA2C206}" dt="2026-07-16T14:31:16.073" v="7504" actId="20577"/>
+        <pc:sldMkLst>
+          <pc:docMk/>
+          <pc:sldMk cId="3578665336" sldId="1041"/>
+        </pc:sldMkLst>
+        <pc:spChg chg="mod">
+          <ac:chgData name="Graf Thomas, SCS-INI-NET-VNC-E2E" userId="487bc3e3-9ce7-4cdd-b7b4-8899ea88d289" providerId="ADAL" clId="{ADEEF08A-D719-4B50-A383-4105EDA2C206}" dt="2026-07-14T12:41:23.213" v="6114" actId="20577"/>
+          <ac:spMkLst>
+            <pc:docMk/>
+            <pc:sldMk cId="3578665336" sldId="1041"/>
+            <ac:spMk id="5" creationId="{C26208B2-0D10-4C23-B2DE-372A62E98644}"/>
+          </ac:spMkLst>
+        </pc:spChg>
+        <pc:spChg chg="mod">
+          <ac:chgData name="Graf Thomas, SCS-INI-NET-VNC-E2E" userId="487bc3e3-9ce7-4cdd-b7b4-8899ea88d289" providerId="ADAL" clId="{ADEEF08A-D719-4B50-A383-4105EDA2C206}" dt="2026-07-16T14:31:16.073" v="7504" actId="20577"/>
+          <ac:spMkLst>
+            <pc:docMk/>
+            <pc:sldMk cId="3578665336" sldId="1041"/>
+            <ac:spMk id="6" creationId="{6CAA0765-1318-4A03-8F91-D3ECC43D8FA7}"/>
+          </ac:spMkLst>
+        </pc:spChg>
+      </pc:sldChg>
+      <pc:sldChg chg="modSp del mod">
+        <pc:chgData name="Graf Thomas, SCS-INI-NET-VNC-E2E" userId="487bc3e3-9ce7-4cdd-b7b4-8899ea88d289" providerId="ADAL" clId="{ADEEF08A-D719-4B50-A383-4105EDA2C206}" dt="2026-07-14T12:55:18.417" v="6196" actId="47"/>
+        <pc:sldMkLst>
+          <pc:docMk/>
+          <pc:sldMk cId="1088069469" sldId="26422"/>
+        </pc:sldMkLst>
+      </pc:sldChg>
+      <pc:sldChg chg="addSp modSp mod">
+        <pc:chgData name="Graf Thomas, SCS-INI-NET-VNC-E2E" userId="487bc3e3-9ce7-4cdd-b7b4-8899ea88d289" providerId="ADAL" clId="{ADEEF08A-D719-4B50-A383-4105EDA2C206}" dt="2026-03-06T15:14:32.681" v="6011" actId="14100"/>
+        <pc:sldMkLst>
+          <pc:docMk/>
+          <pc:sldMk cId="670772560" sldId="2145706220"/>
+        </pc:sldMkLst>
+      </pc:sldChg>
+      <pc:sldChg chg="delSp modSp add mod">
+        <pc:chgData name="Graf Thomas, SCS-INI-NET-VNC-E2E" userId="487bc3e3-9ce7-4cdd-b7b4-8899ea88d289" providerId="ADAL" clId="{ADEEF08A-D719-4B50-A383-4105EDA2C206}" dt="2026-07-14T12:41:55.778" v="6133"/>
+        <pc:sldMkLst>
+          <pc:docMk/>
+          <pc:sldMk cId="2750719351" sldId="2145706243"/>
+        </pc:sldMkLst>
+        <pc:spChg chg="mod">
+          <ac:chgData name="Graf Thomas, SCS-INI-NET-VNC-E2E" userId="487bc3e3-9ce7-4cdd-b7b4-8899ea88d289" providerId="ADAL" clId="{ADEEF08A-D719-4B50-A383-4105EDA2C206}" dt="2026-07-14T12:41:55.778" v="6133"/>
+          <ac:spMkLst>
+            <pc:docMk/>
+            <pc:sldMk cId="2750719351" sldId="2145706243"/>
+            <ac:spMk id="3" creationId="{E1C8AC62-B5C5-ADE4-1957-88D3A14E964A}"/>
+          </ac:spMkLst>
+        </pc:spChg>
+      </pc:sldChg>
+      <pc:sldChg chg="addSp delSp modSp del mod">
+        <pc:chgData name="Graf Thomas, SCS-INI-NET-VNC-E2E" userId="487bc3e3-9ce7-4cdd-b7b4-8899ea88d289" providerId="ADAL" clId="{ADEEF08A-D719-4B50-A383-4105EDA2C206}" dt="2026-07-14T12:55:56.511" v="6197" actId="47"/>
+        <pc:sldMkLst>
+          <pc:docMk/>
+          <pc:sldMk cId="1315775908" sldId="2145706280"/>
+        </pc:sldMkLst>
+      </pc:sldChg>
+      <pc:sldChg chg="addSp delSp modSp del mod">
+        <pc:chgData name="Graf Thomas, SCS-INI-NET-VNC-E2E" userId="487bc3e3-9ce7-4cdd-b7b4-8899ea88d289" providerId="ADAL" clId="{ADEEF08A-D719-4B50-A383-4105EDA2C206}" dt="2026-07-14T12:55:56.511" v="6197" actId="47"/>
+        <pc:sldMkLst>
+          <pc:docMk/>
+          <pc:sldMk cId="3685482022" sldId="2145706295"/>
+        </pc:sldMkLst>
+      </pc:sldChg>
+      <pc:sldChg chg="addSp delSp modSp del mod">
+        <pc:chgData name="Graf Thomas, SCS-INI-NET-VNC-E2E" userId="487bc3e3-9ce7-4cdd-b7b4-8899ea88d289" providerId="ADAL" clId="{ADEEF08A-D719-4B50-A383-4105EDA2C206}" dt="2026-07-14T12:56:53.974" v="6205" actId="47"/>
+        <pc:sldMkLst>
+          <pc:docMk/>
+          <pc:sldMk cId="1475201924" sldId="2145706296"/>
+        </pc:sldMkLst>
+      </pc:sldChg>
+      <pc:sldChg chg="addSp delSp modSp del mod">
+        <pc:chgData name="Graf Thomas, SCS-INI-NET-VNC-E2E" userId="487bc3e3-9ce7-4cdd-b7b4-8899ea88d289" providerId="ADAL" clId="{ADEEF08A-D719-4B50-A383-4105EDA2C206}" dt="2026-07-14T12:56:44.698" v="6204" actId="47"/>
+        <pc:sldMkLst>
+          <pc:docMk/>
+          <pc:sldMk cId="710783608" sldId="2145706297"/>
+        </pc:sldMkLst>
+      </pc:sldChg>
+      <pc:sldChg chg="addSp delSp modSp mod ord">
+        <pc:chgData name="Graf Thomas, SCS-INI-NET-VNC-E2E" userId="487bc3e3-9ce7-4cdd-b7b4-8899ea88d289" providerId="ADAL" clId="{ADEEF08A-D719-4B50-A383-4105EDA2C206}" dt="2026-07-14T12:56:59.627" v="6207"/>
+        <pc:sldMkLst>
+          <pc:docMk/>
+          <pc:sldMk cId="3625312977" sldId="2145706298"/>
+        </pc:sldMkLst>
+        <pc:picChg chg="add mod">
+          <ac:chgData name="Graf Thomas, SCS-INI-NET-VNC-E2E" userId="487bc3e3-9ce7-4cdd-b7b4-8899ea88d289" providerId="ADAL" clId="{ADEEF08A-D719-4B50-A383-4105EDA2C206}" dt="2026-07-14T12:56:39.058" v="6203" actId="1076"/>
+          <ac:picMkLst>
+            <pc:docMk/>
+            <pc:sldMk cId="3625312977" sldId="2145706298"/>
+            <ac:picMk id="3" creationId="{3D20887A-63D9-A4B9-AA81-58DA821129FA}"/>
+          </ac:picMkLst>
+        </pc:picChg>
+      </pc:sldChg>
+      <pc:sldChg chg="del">
+        <pc:chgData name="Graf Thomas, SCS-INI-NET-VNC-E2E" userId="487bc3e3-9ce7-4cdd-b7b4-8899ea88d289" providerId="ADAL" clId="{ADEEF08A-D719-4B50-A383-4105EDA2C206}" dt="2026-03-06T12:57:35.600" v="1725" actId="47"/>
+        <pc:sldMkLst>
+          <pc:docMk/>
+          <pc:sldMk cId="2117458142" sldId="2145706299"/>
+        </pc:sldMkLst>
+      </pc:sldChg>
+      <pc:sldChg chg="del">
+        <pc:chgData name="Graf Thomas, SCS-INI-NET-VNC-E2E" userId="487bc3e3-9ce7-4cdd-b7b4-8899ea88d289" providerId="ADAL" clId="{ADEEF08A-D719-4B50-A383-4105EDA2C206}" dt="2026-07-14T12:55:18.417" v="6196" actId="47"/>
+        <pc:sldMkLst>
+          <pc:docMk/>
+          <pc:sldMk cId="1230411846" sldId="2145706300"/>
+        </pc:sldMkLst>
+      </pc:sldChg>
+      <pc:sldChg chg="modSp del mod">
+        <pc:chgData name="Graf Thomas, SCS-INI-NET-VNC-E2E" userId="487bc3e3-9ce7-4cdd-b7b4-8899ea88d289" providerId="ADAL" clId="{ADEEF08A-D719-4B50-A383-4105EDA2C206}" dt="2026-07-14T12:55:18.417" v="6196" actId="47"/>
+        <pc:sldMkLst>
+          <pc:docMk/>
+          <pc:sldMk cId="4162477740" sldId="2145706301"/>
+        </pc:sldMkLst>
+      </pc:sldChg>
+      <pc:sldChg chg="modSp mod ord">
+        <pc:chgData name="Graf Thomas, SCS-INI-NET-VNC-E2E" userId="487bc3e3-9ce7-4cdd-b7b4-8899ea88d289" providerId="ADAL" clId="{ADEEF08A-D719-4B50-A383-4105EDA2C206}" dt="2026-07-14T13:29:47.977" v="7257" actId="400"/>
+        <pc:sldMkLst>
+          <pc:docMk/>
+          <pc:sldMk cId="1190312228" sldId="2145706302"/>
+        </pc:sldMkLst>
+      </pc:sldChg>
+      <pc:sldChg chg="addSp modSp mod ord">
+        <pc:chgData name="Graf Thomas, SCS-INI-NET-VNC-E2E" userId="487bc3e3-9ce7-4cdd-b7b4-8899ea88d289" providerId="ADAL" clId="{ADEEF08A-D719-4B50-A383-4105EDA2C206}" dt="2026-07-14T13:14:24.593" v="6603" actId="13926"/>
+        <pc:sldMkLst>
+          <pc:docMk/>
+          <pc:sldMk cId="4251917088" sldId="2145706303"/>
+        </pc:sldMkLst>
+        <pc:spChg chg="mod">
+          <ac:chgData name="Graf Thomas, SCS-INI-NET-VNC-E2E" userId="487bc3e3-9ce7-4cdd-b7b4-8899ea88d289" providerId="ADAL" clId="{ADEEF08A-D719-4B50-A383-4105EDA2C206}" dt="2026-07-14T13:14:03.698" v="6600" actId="20577"/>
+          <ac:spMkLst>
+            <pc:docMk/>
+            <pc:sldMk cId="4251917088" sldId="2145706303"/>
+            <ac:spMk id="2" creationId="{9D734BEF-C196-3BAF-0F2E-FB66BF042884}"/>
+          </ac:spMkLst>
+        </pc:spChg>
+        <pc:spChg chg="mod">
+          <ac:chgData name="Graf Thomas, SCS-INI-NET-VNC-E2E" userId="487bc3e3-9ce7-4cdd-b7b4-8899ea88d289" providerId="ADAL" clId="{ADEEF08A-D719-4B50-A383-4105EDA2C206}" dt="2026-07-14T13:06:13.034" v="6332" actId="20577"/>
+          <ac:spMkLst>
+            <pc:docMk/>
+            <pc:sldMk cId="4251917088" sldId="2145706303"/>
+            <ac:spMk id="3" creationId="{6EA985DA-ABCF-AB10-5C45-1B7050950E17}"/>
+          </ac:spMkLst>
+        </pc:spChg>
+        <pc:spChg chg="add mod">
+          <ac:chgData name="Graf Thomas, SCS-INI-NET-VNC-E2E" userId="487bc3e3-9ce7-4cdd-b7b4-8899ea88d289" providerId="ADAL" clId="{ADEEF08A-D719-4B50-A383-4105EDA2C206}" dt="2026-07-14T13:14:24.593" v="6603" actId="13926"/>
+          <ac:spMkLst>
+            <pc:docMk/>
+            <pc:sldMk cId="4251917088" sldId="2145706303"/>
+            <ac:spMk id="5" creationId="{9656C51F-D666-FF4B-6E06-11C9E3E8A8A2}"/>
+          </ac:spMkLst>
+        </pc:spChg>
+      </pc:sldChg>
+      <pc:sldChg chg="modSp del mod">
+        <pc:chgData name="Graf Thomas, SCS-INI-NET-VNC-E2E" userId="487bc3e3-9ce7-4cdd-b7b4-8899ea88d289" providerId="ADAL" clId="{ADEEF08A-D719-4B50-A383-4105EDA2C206}" dt="2026-07-14T12:57:44.073" v="6210" actId="47"/>
+        <pc:sldMkLst>
+          <pc:docMk/>
+          <pc:sldMk cId="2204044421" sldId="2145706304"/>
+        </pc:sldMkLst>
+      </pc:sldChg>
+      <pc:sldChg chg="modSp del mod ord">
+        <pc:chgData name="Graf Thomas, SCS-INI-NET-VNC-E2E" userId="487bc3e3-9ce7-4cdd-b7b4-8899ea88d289" providerId="ADAL" clId="{ADEEF08A-D719-4B50-A383-4105EDA2C206}" dt="2026-07-14T13:25:45.052" v="6971" actId="47"/>
+        <pc:sldMkLst>
+          <pc:docMk/>
+          <pc:sldMk cId="3686017286" sldId="2145706305"/>
+        </pc:sldMkLst>
+      </pc:sldChg>
+      <pc:sldChg chg="delSp modSp mod">
+        <pc:chgData name="Graf Thomas, SCS-INI-NET-VNC-E2E" userId="487bc3e3-9ce7-4cdd-b7b4-8899ea88d289" providerId="ADAL" clId="{ADEEF08A-D719-4B50-A383-4105EDA2C206}" dt="2026-07-14T13:27:26.795" v="7186" actId="20577"/>
+        <pc:sldMkLst>
+          <pc:docMk/>
+          <pc:sldMk cId="3305081943" sldId="2145706306"/>
+        </pc:sldMkLst>
+        <pc:spChg chg="mod">
+          <ac:chgData name="Graf Thomas, SCS-INI-NET-VNC-E2E" userId="487bc3e3-9ce7-4cdd-b7b4-8899ea88d289" providerId="ADAL" clId="{ADEEF08A-D719-4B50-A383-4105EDA2C206}" dt="2026-07-14T13:25:50.342" v="6972" actId="20577"/>
+          <ac:spMkLst>
+            <pc:docMk/>
+            <pc:sldMk cId="3305081943" sldId="2145706306"/>
+            <ac:spMk id="2" creationId="{B37520E1-A4E0-F3CA-29AD-D2D9ADADBEF0}"/>
+          </ac:spMkLst>
+        </pc:spChg>
+        <pc:spChg chg="mod">
+          <ac:chgData name="Graf Thomas, SCS-INI-NET-VNC-E2E" userId="487bc3e3-9ce7-4cdd-b7b4-8899ea88d289" providerId="ADAL" clId="{ADEEF08A-D719-4B50-A383-4105EDA2C206}" dt="2026-07-14T13:27:26.795" v="7186" actId="20577"/>
+          <ac:spMkLst>
+            <pc:docMk/>
+            <pc:sldMk cId="3305081943" sldId="2145706306"/>
+            <ac:spMk id="3" creationId="{3EA36F6F-A76C-ACD7-BA9E-6565DCCE91FE}"/>
+          </ac:spMkLst>
+        </pc:spChg>
+      </pc:sldChg>
+      <pc:sldChg chg="addSp delSp modSp add del mod">
+        <pc:chgData name="Graf Thomas, SCS-INI-NET-VNC-E2E" userId="487bc3e3-9ce7-4cdd-b7b4-8899ea88d289" providerId="ADAL" clId="{ADEEF08A-D719-4B50-A383-4105EDA2C206}" dt="2026-07-14T12:55:18.417" v="6196" actId="47"/>
+        <pc:sldMkLst>
+          <pc:docMk/>
+          <pc:sldMk cId="2590364080" sldId="2145706307"/>
+        </pc:sldMkLst>
+      </pc:sldChg>
+      <pc:sldChg chg="addSp delSp modSp add del mod">
+        <pc:chgData name="Graf Thomas, SCS-INI-NET-VNC-E2E" userId="487bc3e3-9ce7-4cdd-b7b4-8899ea88d289" providerId="ADAL" clId="{ADEEF08A-D719-4B50-A383-4105EDA2C206}" dt="2026-07-14T12:55:18.417" v="6196" actId="47"/>
+        <pc:sldMkLst>
+          <pc:docMk/>
+          <pc:sldMk cId="1296954665" sldId="2145706308"/>
+        </pc:sldMkLst>
+      </pc:sldChg>
+      <pc:sldChg chg="addSp delSp modSp add del mod">
+        <pc:chgData name="Graf Thomas, SCS-INI-NET-VNC-E2E" userId="487bc3e3-9ce7-4cdd-b7b4-8899ea88d289" providerId="ADAL" clId="{ADEEF08A-D719-4B50-A383-4105EDA2C206}" dt="2026-07-14T13:29:15.698" v="7256" actId="20577"/>
+        <pc:sldMkLst>
+          <pc:docMk/>
+          <pc:sldMk cId="2961389282" sldId="2145706309"/>
+        </pc:sldMkLst>
+        <pc:spChg chg="mod">
+          <ac:chgData name="Graf Thomas, SCS-INI-NET-VNC-E2E" userId="487bc3e3-9ce7-4cdd-b7b4-8899ea88d289" providerId="ADAL" clId="{ADEEF08A-D719-4B50-A383-4105EDA2C206}" dt="2026-07-14T13:29:15.698" v="7256" actId="20577"/>
+          <ac:spMkLst>
+            <pc:docMk/>
+            <pc:sldMk cId="2961389282" sldId="2145706309"/>
+            <ac:spMk id="3" creationId="{3F4CBE7F-1450-A754-E524-9EE662BEDE60}"/>
+          </ac:spMkLst>
+        </pc:spChg>
+      </pc:sldChg>
+      <pc:sldChg chg="modSp add del mod">
+        <pc:chgData name="Graf Thomas, SCS-INI-NET-VNC-E2E" userId="487bc3e3-9ce7-4cdd-b7b4-8899ea88d289" providerId="ADAL" clId="{ADEEF08A-D719-4B50-A383-4105EDA2C206}" dt="2026-07-14T12:54:53.444" v="6195" actId="47"/>
+        <pc:sldMkLst>
+          <pc:docMk/>
+          <pc:sldMk cId="3526121720" sldId="2145706310"/>
+        </pc:sldMkLst>
+      </pc:sldChg>
+      <pc:sldChg chg="modSp add mod">
+        <pc:chgData name="Graf Thomas, SCS-INI-NET-VNC-E2E" userId="487bc3e3-9ce7-4cdd-b7b4-8899ea88d289" providerId="ADAL" clId="{ADEEF08A-D719-4B50-A383-4105EDA2C206}" dt="2026-07-16T14:30:57.597" v="7503" actId="20577"/>
+        <pc:sldMkLst>
+          <pc:docMk/>
+          <pc:sldMk cId="4128600093" sldId="2145706310"/>
+        </pc:sldMkLst>
+        <pc:spChg chg="mod">
+          <ac:chgData name="Graf Thomas, SCS-INI-NET-VNC-E2E" userId="487bc3e3-9ce7-4cdd-b7b4-8899ea88d289" providerId="ADAL" clId="{ADEEF08A-D719-4B50-A383-4105EDA2C206}" dt="2026-07-16T14:30:57.597" v="7503" actId="20577"/>
+          <ac:spMkLst>
+            <pc:docMk/>
+            <pc:sldMk cId="4128600093" sldId="2145706310"/>
+            <ac:spMk id="3" creationId="{CB0EE0D0-E2FC-EC67-C3D8-B007AACC1C77}"/>
+          </ac:spMkLst>
+        </pc:spChg>
+      </pc:sldChg>
+      <pc:sldChg chg="add del">
+        <pc:chgData name="Graf Thomas, SCS-INI-NET-VNC-E2E" userId="487bc3e3-9ce7-4cdd-b7b4-8899ea88d289" providerId="ADAL" clId="{ADEEF08A-D719-4B50-A383-4105EDA2C206}" dt="2026-07-14T12:42:45.033" v="6134" actId="47"/>
+        <pc:sldMkLst>
+          <pc:docMk/>
+          <pc:sldMk cId="1403244520" sldId="2145706311"/>
+        </pc:sldMkLst>
+      </pc:sldChg>
+      <pc:sldChg chg="modSp add mod">
+        <pc:chgData name="Graf Thomas, SCS-INI-NET-VNC-E2E" userId="487bc3e3-9ce7-4cdd-b7b4-8899ea88d289" providerId="ADAL" clId="{ADEEF08A-D719-4B50-A383-4105EDA2C206}" dt="2026-07-14T13:23:36.982" v="6930" actId="1076"/>
+        <pc:sldMkLst>
+          <pc:docMk/>
+          <pc:sldMk cId="2687771710" sldId="2145706311"/>
+        </pc:sldMkLst>
+        <pc:spChg chg="mod">
+          <ac:chgData name="Graf Thomas, SCS-INI-NET-VNC-E2E" userId="487bc3e3-9ce7-4cdd-b7b4-8899ea88d289" providerId="ADAL" clId="{ADEEF08A-D719-4B50-A383-4105EDA2C206}" dt="2026-07-14T13:22:33.586" v="6903" actId="5793"/>
+          <ac:spMkLst>
+            <pc:docMk/>
+            <pc:sldMk cId="2687771710" sldId="2145706311"/>
+            <ac:spMk id="2" creationId="{AB2DDFA9-710A-5629-89B2-FB87E211CD78}"/>
+          </ac:spMkLst>
+        </pc:spChg>
+        <pc:spChg chg="mod">
+          <ac:chgData name="Graf Thomas, SCS-INI-NET-VNC-E2E" userId="487bc3e3-9ce7-4cdd-b7b4-8899ea88d289" providerId="ADAL" clId="{ADEEF08A-D719-4B50-A383-4105EDA2C206}" dt="2026-07-14T13:22:55.594" v="6923" actId="20577"/>
+          <ac:spMkLst>
+            <pc:docMk/>
+            <pc:sldMk cId="2687771710" sldId="2145706311"/>
+            <ac:spMk id="3" creationId="{421E468E-B525-66BD-FBA4-8EB776CE47B6}"/>
+          </ac:spMkLst>
+        </pc:spChg>
+        <pc:spChg chg="mod">
+          <ac:chgData name="Graf Thomas, SCS-INI-NET-VNC-E2E" userId="487bc3e3-9ce7-4cdd-b7b4-8899ea88d289" providerId="ADAL" clId="{ADEEF08A-D719-4B50-A383-4105EDA2C206}" dt="2026-07-14T13:23:36.982" v="6930" actId="1076"/>
+          <ac:spMkLst>
+            <pc:docMk/>
+            <pc:sldMk cId="2687771710" sldId="2145706311"/>
+            <ac:spMk id="5" creationId="{2D333956-C5AE-D528-B067-D9A012810329}"/>
+          </ac:spMkLst>
+        </pc:spChg>
+      </pc:sldChg>
+      <pc:sldChg chg="add del">
+        <pc:chgData name="Graf Thomas, SCS-INI-NET-VNC-E2E" userId="487bc3e3-9ce7-4cdd-b7b4-8899ea88d289" providerId="ADAL" clId="{ADEEF08A-D719-4B50-A383-4105EDA2C206}" dt="2026-07-14T12:42:45.033" v="6134" actId="47"/>
+        <pc:sldMkLst>
+          <pc:docMk/>
+          <pc:sldMk cId="632967186" sldId="2145706312"/>
+        </pc:sldMkLst>
+      </pc:sldChg>
+      <pc:sldChg chg="modSp add mod">
+        <pc:chgData name="Graf Thomas, SCS-INI-NET-VNC-E2E" userId="487bc3e3-9ce7-4cdd-b7b4-8899ea88d289" providerId="ADAL" clId="{ADEEF08A-D719-4B50-A383-4105EDA2C206}" dt="2026-07-14T13:23:50.593" v="6938" actId="20577"/>
+        <pc:sldMkLst>
+          <pc:docMk/>
+          <pc:sldMk cId="3807185294" sldId="2145706312"/>
+        </pc:sldMkLst>
+        <pc:spChg chg="mod">
+          <ac:chgData name="Graf Thomas, SCS-INI-NET-VNC-E2E" userId="487bc3e3-9ce7-4cdd-b7b4-8899ea88d289" providerId="ADAL" clId="{ADEEF08A-D719-4B50-A383-4105EDA2C206}" dt="2026-07-14T13:23:50.593" v="6938" actId="20577"/>
+          <ac:spMkLst>
+            <pc:docMk/>
+            <pc:sldMk cId="3807185294" sldId="2145706312"/>
+            <ac:spMk id="2" creationId="{5B8888DB-A90D-A25F-9FAA-CB0DFB34C2A9}"/>
+          </ac:spMkLst>
+        </pc:spChg>
+        <pc:spChg chg="mod">
+          <ac:chgData name="Graf Thomas, SCS-INI-NET-VNC-E2E" userId="487bc3e3-9ce7-4cdd-b7b4-8899ea88d289" providerId="ADAL" clId="{ADEEF08A-D719-4B50-A383-4105EDA2C206}" dt="2026-07-14T13:18:52.189" v="6783" actId="20577"/>
+          <ac:spMkLst>
+            <pc:docMk/>
+            <pc:sldMk cId="3807185294" sldId="2145706312"/>
+            <ac:spMk id="3" creationId="{D1A52B7B-3570-1B5D-1F67-9B38890F5748}"/>
+          </ac:spMkLst>
+        </pc:spChg>
+        <pc:spChg chg="mod">
+          <ac:chgData name="Graf Thomas, SCS-INI-NET-VNC-E2E" userId="487bc3e3-9ce7-4cdd-b7b4-8899ea88d289" providerId="ADAL" clId="{ADEEF08A-D719-4B50-A383-4105EDA2C206}" dt="2026-07-14T13:21:02.081" v="6809" actId="13926"/>
+          <ac:spMkLst>
+            <pc:docMk/>
+            <pc:sldMk cId="3807185294" sldId="2145706312"/>
+            <ac:spMk id="5" creationId="{ACF3B6D0-4561-839A-14B8-04636B057F64}"/>
+          </ac:spMkLst>
+        </pc:spChg>
+      </pc:sldChg>
+      <pc:sldChg chg="modSp add mod ord">
+        <pc:chgData name="Graf Thomas, SCS-INI-NET-VNC-E2E" userId="487bc3e3-9ce7-4cdd-b7b4-8899ea88d289" providerId="ADAL" clId="{ADEEF08A-D719-4B50-A383-4105EDA2C206}" dt="2026-07-16T14:29:56.742" v="7486" actId="20577"/>
+        <pc:sldMkLst>
+          <pc:docMk/>
+          <pc:sldMk cId="1452467401" sldId="2145706313"/>
+        </pc:sldMkLst>
+        <pc:spChg chg="mod">
+          <ac:chgData name="Graf Thomas, SCS-INI-NET-VNC-E2E" userId="487bc3e3-9ce7-4cdd-b7b4-8899ea88d289" providerId="ADAL" clId="{ADEEF08A-D719-4B50-A383-4105EDA2C206}" dt="2026-07-14T13:21:32.190" v="6845" actId="20577"/>
+          <ac:spMkLst>
+            <pc:docMk/>
+            <pc:sldMk cId="1452467401" sldId="2145706313"/>
+            <ac:spMk id="2" creationId="{8DE65009-4589-3EEA-F6BA-6387E69395C3}"/>
+          </ac:spMkLst>
+        </pc:spChg>
+        <pc:spChg chg="mod">
+          <ac:chgData name="Graf Thomas, SCS-INI-NET-VNC-E2E" userId="487bc3e3-9ce7-4cdd-b7b4-8899ea88d289" providerId="ADAL" clId="{ADEEF08A-D719-4B50-A383-4105EDA2C206}" dt="2026-07-16T14:29:56.742" v="7486" actId="20577"/>
+          <ac:spMkLst>
+            <pc:docMk/>
+            <pc:sldMk cId="1452467401" sldId="2145706313"/>
+            <ac:spMk id="3" creationId="{BC3C6DC3-F83A-8266-9A3C-EC72FFB72F03}"/>
+          </ac:spMkLst>
+        </pc:spChg>
+      </pc:sldChg>
+      <pc:sldChg chg="add del">
+        <pc:chgData name="Graf Thomas, SCS-INI-NET-VNC-E2E" userId="487bc3e3-9ce7-4cdd-b7b4-8899ea88d289" providerId="ADAL" clId="{ADEEF08A-D719-4B50-A383-4105EDA2C206}" dt="2026-07-14T12:42:45.033" v="6134" actId="47"/>
+        <pc:sldMkLst>
+          <pc:docMk/>
+          <pc:sldMk cId="3870071406" sldId="2145706313"/>
+        </pc:sldMkLst>
+      </pc:sldChg>
+      <pc:sldChg chg="add del">
+        <pc:chgData name="Graf Thomas, SCS-INI-NET-VNC-E2E" userId="487bc3e3-9ce7-4cdd-b7b4-8899ea88d289" providerId="ADAL" clId="{ADEEF08A-D719-4B50-A383-4105EDA2C206}" dt="2026-07-14T12:42:45.033" v="6134" actId="47"/>
+        <pc:sldMkLst>
+          <pc:docMk/>
+          <pc:sldMk cId="2884885474" sldId="2145706314"/>
+        </pc:sldMkLst>
+      </pc:sldChg>
+      <pc:sldChg chg="modSp add del mod">
+        <pc:chgData name="Graf Thomas, SCS-INI-NET-VNC-E2E" userId="487bc3e3-9ce7-4cdd-b7b4-8899ea88d289" providerId="ADAL" clId="{ADEEF08A-D719-4B50-A383-4105EDA2C206}" dt="2026-07-14T12:42:45.033" v="6134" actId="47"/>
+        <pc:sldMkLst>
+          <pc:docMk/>
+          <pc:sldMk cId="822671291" sldId="2145706315"/>
+        </pc:sldMkLst>
+      </pc:sldChg>
+      <pc:sldChg chg="modSp mod">
+        <pc:chgData name="Graf Thomas, SCS-INI-NET-VNC-E2E" userId="487bc3e3-9ce7-4cdd-b7b4-8899ea88d289" providerId="ADAL" clId="{ADEEF08A-D719-4B50-A383-4105EDA2C206}" dt="2026-07-16T14:30:34.526" v="7491" actId="6549"/>
+        <pc:sldMkLst>
+          <pc:docMk/>
+          <pc:sldMk cId="2939312507" sldId="2145706315"/>
+        </pc:sldMkLst>
+        <pc:spChg chg="mod">
+          <ac:chgData name="Graf Thomas, SCS-INI-NET-VNC-E2E" userId="487bc3e3-9ce7-4cdd-b7b4-8899ea88d289" providerId="ADAL" clId="{ADEEF08A-D719-4B50-A383-4105EDA2C206}" dt="2026-07-16T14:30:34.526" v="7491" actId="6549"/>
+          <ac:spMkLst>
+            <pc:docMk/>
+            <pc:sldMk cId="2939312507" sldId="2145706315"/>
+            <ac:spMk id="3" creationId="{C3BE6826-2677-F704-29DF-A2C833731421}"/>
+          </ac:spMkLst>
+        </pc:spChg>
+      </pc:sldChg>
+      <pc:sldChg chg="modSp mod">
+        <pc:chgData name="Graf Thomas, SCS-INI-NET-VNC-E2E" userId="487bc3e3-9ce7-4cdd-b7b4-8899ea88d289" providerId="ADAL" clId="{ADEEF08A-D719-4B50-A383-4105EDA2C206}" dt="2026-07-16T14:30:20.114" v="7487" actId="790"/>
+        <pc:sldMkLst>
+          <pc:docMk/>
+          <pc:sldMk cId="1872852499" sldId="2145706316"/>
+        </pc:sldMkLst>
+        <pc:spChg chg="mod">
+          <ac:chgData name="Graf Thomas, SCS-INI-NET-VNC-E2E" userId="487bc3e3-9ce7-4cdd-b7b4-8899ea88d289" providerId="ADAL" clId="{ADEEF08A-D719-4B50-A383-4105EDA2C206}" dt="2026-07-16T14:30:20.114" v="7487" actId="790"/>
+          <ac:spMkLst>
+            <pc:docMk/>
+            <pc:sldMk cId="1872852499" sldId="2145706316"/>
+            <ac:spMk id="2" creationId="{C139E37C-89FD-6EBA-520E-409ED1136494}"/>
+          </ac:spMkLst>
+        </pc:spChg>
+        <pc:spChg chg="mod">
+          <ac:chgData name="Graf Thomas, SCS-INI-NET-VNC-E2E" userId="487bc3e3-9ce7-4cdd-b7b4-8899ea88d289" providerId="ADAL" clId="{ADEEF08A-D719-4B50-A383-4105EDA2C206}" dt="2026-07-16T14:30:20.114" v="7487" actId="790"/>
+          <ac:spMkLst>
+            <pc:docMk/>
+            <pc:sldMk cId="1872852499" sldId="2145706316"/>
+            <ac:spMk id="3" creationId="{14533B4E-F532-2573-F0DA-58EA96731AA3}"/>
+          </ac:spMkLst>
+        </pc:spChg>
+        <pc:spChg chg="mod">
+          <ac:chgData name="Graf Thomas, SCS-INI-NET-VNC-E2E" userId="487bc3e3-9ce7-4cdd-b7b4-8899ea88d289" providerId="ADAL" clId="{ADEEF08A-D719-4B50-A383-4105EDA2C206}" dt="2026-07-16T14:30:20.114" v="7487" actId="790"/>
+          <ac:spMkLst>
+            <pc:docMk/>
+            <pc:sldMk cId="1872852499" sldId="2145706316"/>
+            <ac:spMk id="5" creationId="{2D7ED6FF-80FC-84F4-9A7F-3E310B55AD18}"/>
+          </ac:spMkLst>
+        </pc:spChg>
+        <pc:spChg chg="mod">
+          <ac:chgData name="Graf Thomas, SCS-INI-NET-VNC-E2E" userId="487bc3e3-9ce7-4cdd-b7b4-8899ea88d289" providerId="ADAL" clId="{ADEEF08A-D719-4B50-A383-4105EDA2C206}" dt="2026-07-16T14:30:20.114" v="7487" actId="790"/>
+          <ac:spMkLst>
+            <pc:docMk/>
+            <pc:sldMk cId="1872852499" sldId="2145706316"/>
+            <ac:spMk id="6" creationId="{AB67B72F-E7A1-6923-AC3C-23DB42139983}"/>
+          </ac:spMkLst>
+        </pc:spChg>
+      </pc:sldChg>
+      <pc:sldChg chg="modSp add del mod">
+        <pc:chgData name="Graf Thomas, SCS-INI-NET-VNC-E2E" userId="487bc3e3-9ce7-4cdd-b7b4-8899ea88d289" providerId="ADAL" clId="{ADEEF08A-D719-4B50-A383-4105EDA2C206}" dt="2026-03-06T15:27:05.528" v="6106" actId="47"/>
+        <pc:sldMkLst>
+          <pc:docMk/>
+          <pc:sldMk cId="3812470375" sldId="2145706316"/>
         </pc:sldMkLst>
       </pc:sldChg>
     </pc:docChg>
@@ -6393,7 +6383,7 @@
               <a:rPr lang="en-US" sz="1400" dirty="0">
                 <a:latin typeface="+mj-lt"/>
               </a:rPr>
-              <a:t>14. July </a:t>
+              <a:t>16. July </a:t>
             </a:r>
             <a:r>
               <a:rPr lang="en-US" sz="1400" dirty="0">
@@ -9941,7 +9931,7 @@
               <a:rPr lang="en-US" sz="2100" dirty="0">
                 <a:latin typeface="Calibri body"/>
               </a:rPr>
-              <a:t>Avoid duplicating BGP semantics already standardized in IDR.</a:t>
+              <a:t>Avoid duplicating BGP semantics already standardized at IDR working group.</a:t>
             </a:r>
           </a:p>
           <a:p>
@@ -9958,7 +9948,7 @@
               <a:rPr lang="en-US" sz="2100" dirty="0">
                 <a:latin typeface="Calibri body"/>
               </a:rPr>
-              <a:t>We have an open request to draft-</a:t>
+              <a:t>draft-</a:t>
             </a:r>
             <a:r>
               <a:rPr lang="en-US" sz="2100" dirty="0" err="1">
@@ -9994,23 +9984,26 @@
               <a:rPr lang="en-US" sz="2100" dirty="0">
                 <a:latin typeface="Calibri body"/>
               </a:rPr>
-              <a:t>-model authors to </a:t>
+              <a:t>-model authors </a:t>
             </a:r>
             <a:r>
               <a:rPr lang="en-US" sz="2100" b="1" dirty="0">
                 <a:latin typeface="Calibri body"/>
-              </a:rPr>
-              <a:t>restructure </a:t>
+                <a:hlinkClick r:id="rId3"/>
+              </a:rPr>
+              <a:t>restructured </a:t>
             </a:r>
             <a:r>
               <a:rPr lang="en-US" sz="2100" b="1" dirty="0" err="1">
                 <a:latin typeface="Calibri body"/>
+                <a:hlinkClick r:id="rId3"/>
               </a:rPr>
               <a:t>ietf-bgp</a:t>
             </a:r>
             <a:r>
               <a:rPr lang="en-US" sz="2100" b="1" dirty="0">
                 <a:latin typeface="Calibri body"/>
+                <a:hlinkClick r:id="rId3"/>
               </a:rPr>
               <a:t> from submodules to standalone reusable modules </a:t>
             </a:r>
@@ -10018,7 +10011,68 @@
               <a:rPr lang="en-US" sz="2100" dirty="0">
                 <a:latin typeface="Calibri body"/>
               </a:rPr>
-              <a:t>(since submodules cannot be imported independently of the main module).</a:t>
+              <a:t>(since submodules cannot be imported independently of the main module) and we are looking forward that these changes are being mirrored to the </a:t>
+            </a:r>
+            <a:r>
+              <a:rPr lang="en-US" sz="2100" b="1" dirty="0">
+                <a:latin typeface="Calibri body"/>
+                <a:hlinkClick r:id="rId2"/>
+              </a:rPr>
+              <a:t>draft-</a:t>
+            </a:r>
+            <a:r>
+              <a:rPr lang="en-US" sz="2100" b="1" dirty="0" err="1">
+                <a:latin typeface="Calibri body"/>
+                <a:hlinkClick r:id="rId2"/>
+              </a:rPr>
+              <a:t>ietf</a:t>
+            </a:r>
+            <a:r>
+              <a:rPr lang="en-US" sz="2100" b="1" dirty="0">
+                <a:latin typeface="Calibri body"/>
+                <a:hlinkClick r:id="rId2"/>
+              </a:rPr>
+              <a:t>-</a:t>
+            </a:r>
+            <a:r>
+              <a:rPr lang="en-US" sz="2100" b="1" dirty="0" err="1">
+                <a:latin typeface="Calibri body"/>
+                <a:hlinkClick r:id="rId2"/>
+              </a:rPr>
+              <a:t>idr</a:t>
+            </a:r>
+            <a:r>
+              <a:rPr lang="en-US" sz="2100" b="1" dirty="0">
+                <a:latin typeface="Calibri body"/>
+                <a:hlinkClick r:id="rId2"/>
+              </a:rPr>
+              <a:t>-</a:t>
+            </a:r>
+            <a:r>
+              <a:rPr lang="en-US" sz="2100" b="1" dirty="0" err="1">
+                <a:latin typeface="Calibri body"/>
+                <a:hlinkClick r:id="rId2"/>
+              </a:rPr>
+              <a:t>bgp</a:t>
+            </a:r>
+            <a:r>
+              <a:rPr lang="en-US" sz="2100" b="1" dirty="0">
+                <a:latin typeface="Calibri body"/>
+                <a:hlinkClick r:id="rId2"/>
+              </a:rPr>
+              <a:t>-model</a:t>
+            </a:r>
+            <a:r>
+              <a:rPr lang="en-US" sz="2100" b="1" dirty="0">
+                <a:latin typeface="Calibri body"/>
+              </a:rPr>
+              <a:t> </a:t>
+            </a:r>
+            <a:r>
+              <a:rPr lang="en-US" sz="2100" dirty="0">
+                <a:latin typeface="Calibri body"/>
+              </a:rPr>
+              <a:t>document.</a:t>
             </a:r>
           </a:p>
           <a:p>
@@ -10035,7 +10089,7 @@
               <a:rPr lang="en-US" sz="2100" dirty="0">
                 <a:latin typeface="Calibri body"/>
               </a:rPr>
-              <a:t>YANG modules in this draft could then be simplified to import only the specific modules needed, avoiding to pull in BGP configuration and policy related content which is not needed for telemetry use cases.</a:t>
+              <a:t>YANG modules in this document could then be simplified to import only the specific modules needed and not importing BGP configuration and policy related schema content which is not needed for telemetry use cases.</a:t>
             </a:r>
             <a:endParaRPr lang="en-US" sz="2100" dirty="0"/>
           </a:p>
@@ -10673,34 +10727,34 @@
           <a:lstStyle/>
           <a:p>
             <a:r>
-              <a:rPr lang="en-US" sz="2800" b="1" dirty="0"/>
+              <a:rPr lang="en-US" sz="2800" b="1" noProof="0" dirty="0"/>
               <a:t>BMP YANG Telemetry Message</a:t>
             </a:r>
             <a:br>
-              <a:rPr lang="en-US" sz="3600" dirty="0"/>
+              <a:rPr lang="en-US" sz="3600" noProof="0" dirty="0"/>
             </a:br>
             <a:r>
-              <a:rPr lang="en-US" sz="2700" dirty="0">
+              <a:rPr lang="en-US" sz="2700" noProof="0" dirty="0">
                 <a:solidFill>
                   <a:schemeClr val="bg2">
                     <a:lumMod val="75000"/>
                   </a:schemeClr>
                 </a:solidFill>
               </a:rPr>
-              <a:t>New `</a:t>
-            </a:r>
-            <a:r>
-              <a:rPr lang="en-US" sz="2700" dirty="0" err="1">
+              <a:t>New </a:t>
+            </a:r>
+            <a:r>
+              <a:rPr lang="en-US" sz="2700" noProof="0" dirty="0" err="1">
                 <a:solidFill>
                   <a:schemeClr val="bg2">
                     <a:lumMod val="75000"/>
                   </a:schemeClr>
                 </a:solidFill>
               </a:rPr>
-              <a:t>ietf</a:t>
-            </a:r>
-            <a:r>
-              <a:rPr lang="en-US" sz="2700" dirty="0">
+              <a:t>`ietf</a:t>
+            </a:r>
+            <a:r>
+              <a:rPr lang="en-US" sz="2700" noProof="0" dirty="0">
                 <a:solidFill>
                   <a:schemeClr val="bg2">
                     <a:lumMod val="75000"/>
@@ -10710,7 +10764,7 @@
               <a:t>-bmp-</a:t>
             </a:r>
             <a:r>
-              <a:rPr lang="en-US" sz="2700" dirty="0" err="1">
+              <a:rPr lang="en-US" sz="2700" noProof="0" dirty="0" err="1">
                 <a:solidFill>
                   <a:schemeClr val="bg2">
                     <a:lumMod val="75000"/>
@@ -10720,7 +10774,7 @@
               <a:t>tlv</a:t>
             </a:r>
             <a:r>
-              <a:rPr lang="en-US" sz="2700" dirty="0">
+              <a:rPr lang="en-US" sz="2700" noProof="0" dirty="0">
                 <a:solidFill>
                   <a:schemeClr val="bg2">
                     <a:lumMod val="75000"/>
@@ -10770,154 +10824,10 @@
               <a:buNone/>
             </a:pPr>
             <a:r>
-              <a:rPr lang="de-CH" sz="2100" dirty="0">
+              <a:rPr lang="en-US" sz="2100" noProof="0" dirty="0">
                 <a:latin typeface="Calibri body"/>
               </a:rPr>
-              <a:t>Dedicated </a:t>
-            </a:r>
-            <a:r>
-              <a:rPr lang="de-CH" sz="2100" dirty="0" err="1">
-                <a:latin typeface="Calibri body"/>
-              </a:rPr>
-              <a:t>module</a:t>
-            </a:r>
-            <a:r>
-              <a:rPr lang="de-CH" sz="2100" dirty="0">
-                <a:latin typeface="Calibri body"/>
-              </a:rPr>
-              <a:t> </a:t>
-            </a:r>
-            <a:r>
-              <a:rPr lang="de-CH" sz="2100" dirty="0" err="1">
-                <a:latin typeface="Calibri body"/>
-              </a:rPr>
-              <a:t>modeling</a:t>
-            </a:r>
-            <a:r>
-              <a:rPr lang="de-CH" sz="2100" dirty="0">
-                <a:latin typeface="Calibri body"/>
-              </a:rPr>
-              <a:t> </a:t>
-            </a:r>
-            <a:r>
-              <a:rPr lang="de-CH" sz="2100" dirty="0" err="1">
-                <a:latin typeface="Calibri body"/>
-              </a:rPr>
-              <a:t>the</a:t>
-            </a:r>
-            <a:r>
-              <a:rPr lang="de-CH" sz="2100" dirty="0">
-                <a:latin typeface="Calibri body"/>
-              </a:rPr>
-              <a:t> </a:t>
-            </a:r>
-            <a:r>
-              <a:rPr lang="de-CH" sz="2100" dirty="0" err="1">
-                <a:latin typeface="Calibri body"/>
-              </a:rPr>
-              <a:t>decoded</a:t>
-            </a:r>
-            <a:r>
-              <a:rPr lang="de-CH" sz="2100" dirty="0">
-                <a:latin typeface="Calibri body"/>
-              </a:rPr>
-              <a:t> </a:t>
-            </a:r>
-            <a:r>
-              <a:rPr lang="de-CH" sz="2100" dirty="0" err="1">
-                <a:latin typeface="Calibri body"/>
-              </a:rPr>
-              <a:t>value</a:t>
-            </a:r>
-            <a:r>
-              <a:rPr lang="de-CH" sz="2100" dirty="0">
-                <a:latin typeface="Calibri body"/>
-              </a:rPr>
-              <a:t> </a:t>
-            </a:r>
-            <a:r>
-              <a:rPr lang="de-CH" sz="2100" dirty="0" err="1">
-                <a:latin typeface="Calibri body"/>
-              </a:rPr>
-              <a:t>of</a:t>
-            </a:r>
-            <a:r>
-              <a:rPr lang="de-CH" sz="2100" dirty="0">
-                <a:latin typeface="Calibri body"/>
-              </a:rPr>
-              <a:t> BMP TLVs, </a:t>
-            </a:r>
-            <a:r>
-              <a:rPr lang="de-CH" sz="2100" dirty="0" err="1">
-                <a:latin typeface="Calibri body"/>
-              </a:rPr>
-              <a:t>consolidates</a:t>
-            </a:r>
-            <a:r>
-              <a:rPr lang="de-CH" sz="2100" dirty="0">
-                <a:latin typeface="Calibri body"/>
-              </a:rPr>
-              <a:t> TLV </a:t>
-            </a:r>
-            <a:r>
-              <a:rPr lang="de-CH" sz="2100" dirty="0" err="1">
-                <a:latin typeface="Calibri body"/>
-              </a:rPr>
-              <a:t>groupings</a:t>
-            </a:r>
-            <a:r>
-              <a:rPr lang="de-CH" sz="2100" dirty="0">
-                <a:latin typeface="Calibri body"/>
-              </a:rPr>
-              <a:t> </a:t>
-            </a:r>
-            <a:r>
-              <a:rPr lang="de-CH" sz="2100" dirty="0" err="1">
-                <a:latin typeface="Calibri body"/>
-              </a:rPr>
-              <a:t>from</a:t>
-            </a:r>
-            <a:r>
-              <a:rPr lang="de-CH" sz="2100" dirty="0">
-                <a:latin typeface="Calibri body"/>
-              </a:rPr>
-              <a:t> multiple </a:t>
-            </a:r>
-            <a:r>
-              <a:rPr lang="de-CH" sz="2100" dirty="0" err="1">
-                <a:latin typeface="Calibri body"/>
-              </a:rPr>
-              <a:t>specs</a:t>
-            </a:r>
-            <a:r>
-              <a:rPr lang="de-CH" sz="2100" dirty="0">
-                <a:latin typeface="Calibri body"/>
-              </a:rPr>
-              <a:t> in </a:t>
-            </a:r>
-            <a:r>
-              <a:rPr lang="de-CH" sz="2100" dirty="0" err="1">
-                <a:latin typeface="Calibri body"/>
-              </a:rPr>
-              <a:t>one</a:t>
-            </a:r>
-            <a:r>
-              <a:rPr lang="de-CH" sz="2100" dirty="0">
-                <a:latin typeface="Calibri body"/>
-              </a:rPr>
-              <a:t> </a:t>
-            </a:r>
-            <a:r>
-              <a:rPr lang="de-CH" sz="2100" dirty="0" err="1">
-                <a:latin typeface="Calibri body"/>
-              </a:rPr>
-              <a:t>place</a:t>
-            </a:r>
-            <a:r>
-              <a:rPr lang="de-CH" sz="2100" dirty="0">
-                <a:latin typeface="Calibri body"/>
-              </a:rPr>
-              <a:t>:</a:t>
+              <a:t>Dedicated module modeling the decoded value of BMP TLVs, consolidates TLV groupings from multiple specs in one place:</a:t>
             </a:r>
           </a:p>
           <a:p>
@@ -10930,14 +10840,14 @@
               </a:spcBef>
             </a:pPr>
             <a:r>
-              <a:rPr lang="de-CH" sz="2100" dirty="0">
+              <a:rPr lang="en-US" sz="2100" noProof="0" dirty="0">
                 <a:latin typeface="Calibri body"/>
                 <a:hlinkClick r:id="rId2"/>
               </a:rPr>
               <a:t>RFC 7854</a:t>
             </a:r>
             <a:r>
-              <a:rPr lang="de-CH" sz="2100" dirty="0">
+              <a:rPr lang="en-US" sz="2100" noProof="0" dirty="0">
                 <a:latin typeface="Calibri body"/>
               </a:rPr>
               <a:t> (BMP): Info, Term, RM TLVs</a:t>
@@ -10953,29 +10863,17 @@
               </a:spcBef>
             </a:pPr>
             <a:r>
-              <a:rPr lang="de-CH" sz="2100" dirty="0">
+              <a:rPr lang="en-US" sz="2100" noProof="0" dirty="0">
                 <a:latin typeface="Calibri body"/>
                 <a:hlinkClick r:id="rId3"/>
               </a:rPr>
               <a:t>RFC 9069 </a:t>
             </a:r>
             <a:r>
-              <a:rPr lang="de-CH" sz="2100" dirty="0">
+              <a:rPr lang="en-US" sz="2100" noProof="0" dirty="0">
                 <a:latin typeface="Calibri body"/>
               </a:rPr>
-              <a:t>(</a:t>
-            </a:r>
-            <a:r>
-              <a:rPr lang="de-CH" sz="2100" dirty="0" err="1">
-                <a:latin typeface="Calibri body"/>
-              </a:rPr>
-              <a:t>Loc-Rib</a:t>
-            </a:r>
-            <a:r>
-              <a:rPr lang="de-CH" sz="2100" dirty="0">
-                <a:latin typeface="Calibri body"/>
-              </a:rPr>
-              <a:t>): VRF/Table Name TLV</a:t>
+              <a:t>(Loc-Rib): VRF/Table Name TLV</a:t>
             </a:r>
           </a:p>
           <a:p>
@@ -10988,14 +10886,14 @@
               </a:spcBef>
             </a:pPr>
             <a:r>
-              <a:rPr lang="de-CH" sz="2100" dirty="0">
+              <a:rPr lang="en-US" sz="2100" noProof="0" dirty="0">
                 <a:latin typeface="Calibri body"/>
                 <a:hlinkClick r:id="rId4"/>
               </a:rPr>
               <a:t>draft-ietf-grow-bmp-tlv</a:t>
             </a:r>
             <a:r>
-              <a:rPr lang="de-CH" sz="2100" dirty="0">
+              <a:rPr lang="en-US" sz="2100" noProof="0" dirty="0">
                 <a:latin typeface="Calibri body"/>
               </a:rPr>
               <a:t> (BMP v4)</a:t>
@@ -11010,7 +10908,7 @@
                 <a:spcPts val="0"/>
               </a:spcBef>
             </a:pPr>
-            <a:endParaRPr lang="de-CH" sz="2100" dirty="0">
+            <a:endParaRPr lang="en-US" sz="2100" noProof="0" dirty="0">
               <a:latin typeface="Calibri body"/>
             </a:endParaRPr>
           </a:p>
@@ -11025,240 +10923,12 @@
               <a:buNone/>
             </a:pPr>
             <a:r>
-              <a:rPr lang="de-CH" sz="2100" dirty="0">
+              <a:rPr lang="en-US" sz="2100" noProof="0" dirty="0">
                 <a:latin typeface="Calibri body"/>
               </a:rPr>
-              <a:t>Message-type </a:t>
-            </a:r>
-            <a:r>
-              <a:rPr lang="de-CH" sz="2100" dirty="0" err="1">
-                <a:latin typeface="Calibri body"/>
-              </a:rPr>
-              <a:t>specific</a:t>
-            </a:r>
-            <a:r>
-              <a:rPr lang="de-CH" sz="2100" dirty="0">
-                <a:latin typeface="Calibri body"/>
-              </a:rPr>
-              <a:t> </a:t>
-            </a:r>
-            <a:r>
-              <a:rPr lang="de-CH" sz="2100" dirty="0" err="1">
-                <a:latin typeface="Calibri body"/>
-              </a:rPr>
-              <a:t>groupings</a:t>
-            </a:r>
-            <a:r>
-              <a:rPr lang="de-CH" sz="2100" dirty="0">
-                <a:latin typeface="Calibri body"/>
-              </a:rPr>
-              <a:t> </a:t>
-            </a:r>
-            <a:r>
-              <a:rPr lang="de-CH" sz="2100" dirty="0" err="1">
-                <a:latin typeface="Calibri body"/>
-              </a:rPr>
-              <a:t>are</a:t>
-            </a:r>
-            <a:r>
-              <a:rPr lang="de-CH" sz="2100" dirty="0">
-                <a:latin typeface="Calibri body"/>
-              </a:rPr>
-              <a:t> </a:t>
-            </a:r>
-            <a:r>
-              <a:rPr lang="de-CH" sz="2100" dirty="0" err="1">
-                <a:latin typeface="Calibri body"/>
-              </a:rPr>
-              <a:t>provided</a:t>
-            </a:r>
-            <a:r>
-              <a:rPr lang="de-CH" sz="2100" dirty="0">
-                <a:latin typeface="Calibri body"/>
-              </a:rPr>
-              <a:t>, </a:t>
-            </a:r>
-            <a:r>
-              <a:rPr lang="de-CH" sz="2100" dirty="0" err="1">
-                <a:latin typeface="Calibri body"/>
-              </a:rPr>
-              <a:t>to</a:t>
-            </a:r>
-            <a:r>
-              <a:rPr lang="de-CH" sz="2100" dirty="0">
-                <a:latin typeface="Calibri body"/>
-              </a:rPr>
-              <a:t> </a:t>
-            </a:r>
-            <a:r>
-              <a:rPr lang="de-CH" sz="2100" dirty="0" err="1">
-                <a:latin typeface="Calibri body"/>
-              </a:rPr>
-              <a:t>determine</a:t>
-            </a:r>
-            <a:r>
-              <a:rPr lang="de-CH" sz="2100" dirty="0">
-                <a:latin typeface="Calibri body"/>
-              </a:rPr>
-              <a:t> </a:t>
-            </a:r>
-            <a:r>
-              <a:rPr lang="de-CH" sz="2100" dirty="0" err="1">
-                <a:latin typeface="Calibri body"/>
-              </a:rPr>
-              <a:t>which</a:t>
-            </a:r>
-            <a:r>
-              <a:rPr lang="de-CH" sz="2100" dirty="0">
-                <a:latin typeface="Calibri body"/>
-              </a:rPr>
-              <a:t> TLVs </a:t>
-            </a:r>
-            <a:r>
-              <a:rPr lang="de-CH" sz="2100" dirty="0" err="1">
-                <a:latin typeface="Calibri body"/>
-              </a:rPr>
-              <a:t>are</a:t>
-            </a:r>
-            <a:r>
-              <a:rPr lang="de-CH" sz="2100" dirty="0">
-                <a:latin typeface="Calibri body"/>
-              </a:rPr>
-              <a:t> </a:t>
-            </a:r>
-            <a:r>
-              <a:rPr lang="de-CH" sz="2100" dirty="0" err="1">
-                <a:latin typeface="Calibri body"/>
-              </a:rPr>
-              <a:t>applicable</a:t>
-            </a:r>
-            <a:r>
-              <a:rPr lang="de-CH" sz="2100" dirty="0">
-                <a:latin typeface="Calibri body"/>
-              </a:rPr>
-              <a:t>. All </a:t>
-            </a:r>
-            <a:r>
-              <a:rPr lang="de-CH" sz="2100" dirty="0" err="1">
-                <a:latin typeface="Calibri body"/>
-              </a:rPr>
-              <a:t>message-types</a:t>
-            </a:r>
-            <a:r>
-              <a:rPr lang="de-CH" sz="2100" dirty="0">
-                <a:latin typeface="Calibri body"/>
-              </a:rPr>
-              <a:t> </a:t>
-            </a:r>
-            <a:r>
-              <a:rPr lang="de-CH" sz="2100" dirty="0" err="1">
-                <a:latin typeface="Calibri body"/>
-              </a:rPr>
-              <a:t>have</a:t>
-            </a:r>
-            <a:r>
-              <a:rPr lang="de-CH" sz="2100" dirty="0">
-                <a:latin typeface="Calibri body"/>
-              </a:rPr>
-              <a:t> a </a:t>
-            </a:r>
-            <a:r>
-              <a:rPr lang="de-CH" sz="2100" dirty="0" err="1">
-                <a:latin typeface="Calibri body"/>
-              </a:rPr>
-              <a:t>common</a:t>
-            </a:r>
-            <a:r>
-              <a:rPr lang="de-CH" sz="2100" dirty="0">
-                <a:latin typeface="Calibri body"/>
-              </a:rPr>
-              <a:t> </a:t>
-            </a:r>
-            <a:r>
-              <a:rPr lang="de-CH" sz="2100" dirty="0" err="1">
-                <a:latin typeface="Calibri body"/>
-              </a:rPr>
-              <a:t>set</a:t>
-            </a:r>
-            <a:r>
-              <a:rPr lang="de-CH" sz="2100" dirty="0">
-                <a:latin typeface="Calibri body"/>
-              </a:rPr>
-              <a:t> </a:t>
-            </a:r>
-            <a:r>
-              <a:rPr lang="de-CH" sz="2100" dirty="0" err="1">
-                <a:latin typeface="Calibri body"/>
-              </a:rPr>
-              <a:t>of</a:t>
-            </a:r>
-            <a:r>
-              <a:rPr lang="de-CH" sz="2100" dirty="0">
-                <a:latin typeface="Calibri body"/>
-              </a:rPr>
-              <a:t> TLVs </a:t>
-            </a:r>
-            <a:r>
-              <a:rPr lang="de-CH" sz="2100" dirty="0" err="1">
-                <a:latin typeface="Calibri body"/>
-              </a:rPr>
-              <a:t>represented</a:t>
-            </a:r>
-            <a:r>
-              <a:rPr lang="de-CH" sz="2100" dirty="0">
-                <a:latin typeface="Calibri body"/>
-              </a:rPr>
-              <a:t> </a:t>
-            </a:r>
-            <a:r>
-              <a:rPr lang="de-CH" sz="2100" dirty="0" err="1">
-                <a:latin typeface="Calibri body"/>
-              </a:rPr>
-              <a:t>by</a:t>
-            </a:r>
-            <a:r>
-              <a:rPr lang="de-CH" sz="2100" dirty="0">
-                <a:latin typeface="Calibri body"/>
-              </a:rPr>
-              <a:t> </a:t>
-            </a:r>
-            <a:r>
-              <a:rPr lang="de-CH" sz="2100" dirty="0" err="1">
-                <a:latin typeface="Calibri body"/>
-              </a:rPr>
-              <a:t>sequence-number</a:t>
-            </a:r>
-            <a:r>
-              <a:rPr lang="de-CH" sz="2100" dirty="0">
-                <a:latin typeface="Calibri body"/>
-              </a:rPr>
-              <a:t>, </a:t>
-            </a:r>
-            <a:r>
-              <a:rPr lang="de-CH" sz="2100" dirty="0" err="1">
-                <a:latin typeface="Calibri body"/>
-              </a:rPr>
-              <a:t>timestamps</a:t>
-            </a:r>
-            <a:r>
-              <a:rPr lang="de-CH" sz="2100" dirty="0">
-                <a:latin typeface="Calibri body"/>
-              </a:rPr>
-              <a:t>, and </a:t>
-            </a:r>
-            <a:r>
-              <a:rPr lang="de-CH" sz="2100" dirty="0" err="1">
-                <a:latin typeface="Calibri body"/>
-              </a:rPr>
-              <a:t>extended-flags</a:t>
-            </a:r>
-            <a:r>
-              <a:rPr lang="de-CH" sz="2100" dirty="0">
-                <a:latin typeface="Calibri body"/>
-              </a:rPr>
-              <a:t>. </a:t>
-            </a:r>
-            <a:endParaRPr lang="en-US" sz="2100" dirty="0"/>
+              <a:t>Message-type specific groupings are provided, to determine which TLVs are applicable. All message-types have a common set of TLVs represented by sequence-number, timestamps, and extended-flags. </a:t>
+            </a:r>
+            <a:endParaRPr lang="en-US" sz="2100" noProof="0" dirty="0"/>
           </a:p>
         </p:txBody>
       </p:sp>
@@ -11289,10 +10959,10 @@
           <a:lstStyle/>
           <a:p>
             <a:fld id="{FC4AC485-25DE-431E-B345-9C0A15BB7F8A}" type="slidenum">
-              <a:rPr lang="en-US" sz="1400" smtClean="0"/>
+              <a:rPr lang="en-US" sz="1400" noProof="0" smtClean="0"/>
               <a:t>5</a:t>
             </a:fld>
-            <a:endParaRPr lang="en-US" sz="1400" dirty="0"/>
+            <a:endParaRPr lang="en-US" sz="1400" noProof="0" dirty="0"/>
           </a:p>
         </p:txBody>
       </p:sp>
@@ -11325,131 +10995,54 @@
           <a:lstStyle/>
           <a:p>
             <a:r>
-              <a:rPr lang="de-CH" sz="900" dirty="0" err="1">
-                <a:latin typeface="Courier New" panose="02070309020205020404" pitchFamily="49" charset="0"/>
-                <a:cs typeface="Courier New" panose="02070309020205020404" pitchFamily="49" charset="0"/>
-              </a:rPr>
-              <a:t>module</a:t>
-            </a:r>
-            <a:r>
-              <a:rPr lang="de-CH" sz="900" dirty="0">
-                <a:latin typeface="Courier New" panose="02070309020205020404" pitchFamily="49" charset="0"/>
-                <a:cs typeface="Courier New" panose="02070309020205020404" pitchFamily="49" charset="0"/>
-              </a:rPr>
-              <a:t>: </a:t>
-            </a:r>
-            <a:r>
-              <a:rPr lang="de-CH" sz="900" dirty="0" err="1">
+              <a:rPr lang="en-US" sz="900" noProof="0" dirty="0">
+                <a:latin typeface="Courier New" panose="02070309020205020404" pitchFamily="49" charset="0"/>
+                <a:cs typeface="Courier New" panose="02070309020205020404" pitchFamily="49" charset="0"/>
+              </a:rPr>
+              <a:t>module: </a:t>
+            </a:r>
+            <a:r>
+              <a:rPr lang="en-US" sz="900" noProof="0" dirty="0" err="1">
                 <a:latin typeface="Courier New" panose="02070309020205020404" pitchFamily="49" charset="0"/>
                 <a:cs typeface="Courier New" panose="02070309020205020404" pitchFamily="49" charset="0"/>
               </a:rPr>
               <a:t>ietf</a:t>
             </a:r>
             <a:r>
-              <a:rPr lang="de-CH" sz="900" dirty="0">
-                <a:latin typeface="Courier New" panose="02070309020205020404" pitchFamily="49" charset="0"/>
-                <a:cs typeface="Courier New" panose="02070309020205020404" pitchFamily="49" charset="0"/>
-              </a:rPr>
-              <a:t>-</a:t>
-            </a:r>
-            <a:r>
-              <a:rPr lang="de-CH" sz="900" dirty="0" err="1">
-                <a:latin typeface="Courier New" panose="02070309020205020404" pitchFamily="49" charset="0"/>
-                <a:cs typeface="Courier New" panose="02070309020205020404" pitchFamily="49" charset="0"/>
-              </a:rPr>
-              <a:t>bmp</a:t>
-            </a:r>
-            <a:r>
-              <a:rPr lang="de-CH" sz="900" dirty="0">
-                <a:latin typeface="Courier New" panose="02070309020205020404" pitchFamily="49" charset="0"/>
-                <a:cs typeface="Courier New" panose="02070309020205020404" pitchFamily="49" charset="0"/>
-              </a:rPr>
-              <a:t>-</a:t>
-            </a:r>
-            <a:r>
-              <a:rPr lang="de-CH" sz="900" dirty="0" err="1">
-                <a:latin typeface="Courier New" panose="02070309020205020404" pitchFamily="49" charset="0"/>
-                <a:cs typeface="Courier New" panose="02070309020205020404" pitchFamily="49" charset="0"/>
-              </a:rPr>
-              <a:t>telemetry</a:t>
-            </a:r>
-            <a:r>
-              <a:rPr lang="de-CH" sz="900" dirty="0">
-                <a:latin typeface="Courier New" panose="02070309020205020404" pitchFamily="49" charset="0"/>
-                <a:cs typeface="Courier New" panose="02070309020205020404" pitchFamily="49" charset="0"/>
-              </a:rPr>
-              <a:t>-message</a:t>
-            </a:r>
-          </a:p>
-          <a:p>
-            <a:endParaRPr lang="de-CH" sz="900" dirty="0">
+              <a:rPr lang="en-US" sz="900" noProof="0" dirty="0">
+                <a:latin typeface="Courier New" panose="02070309020205020404" pitchFamily="49" charset="0"/>
+                <a:cs typeface="Courier New" panose="02070309020205020404" pitchFamily="49" charset="0"/>
+              </a:rPr>
+              <a:t>-bmp-telemetry-message</a:t>
+            </a:r>
+          </a:p>
+          <a:p>
+            <a:endParaRPr lang="en-US" sz="900" noProof="0" dirty="0">
               <a:latin typeface="Courier New" panose="02070309020205020404" pitchFamily="49" charset="0"/>
               <a:cs typeface="Courier New" panose="02070309020205020404" pitchFamily="49" charset="0"/>
             </a:endParaRPr>
           </a:p>
           <a:p>
             <a:r>
-              <a:rPr lang="de-CH" sz="900" dirty="0">
-                <a:latin typeface="Courier New" panose="02070309020205020404" pitchFamily="49" charset="0"/>
-                <a:cs typeface="Courier New" panose="02070309020205020404" pitchFamily="49" charset="0"/>
-              </a:rPr>
-              <a:t>  </a:t>
-            </a:r>
-            <a:r>
-              <a:rPr lang="de-CH" sz="900" dirty="0" err="1">
-                <a:latin typeface="Courier New" panose="02070309020205020404" pitchFamily="49" charset="0"/>
-                <a:cs typeface="Courier New" panose="02070309020205020404" pitchFamily="49" charset="0"/>
-              </a:rPr>
-              <a:t>structure</a:t>
-            </a:r>
-            <a:r>
-              <a:rPr lang="de-CH" sz="900" dirty="0">
-                <a:latin typeface="Courier New" panose="02070309020205020404" pitchFamily="49" charset="0"/>
-                <a:cs typeface="Courier New" panose="02070309020205020404" pitchFamily="49" charset="0"/>
-              </a:rPr>
-              <a:t> </a:t>
-            </a:r>
-            <a:r>
-              <a:rPr lang="de-CH" sz="900" dirty="0" err="1">
-                <a:latin typeface="Courier New" panose="02070309020205020404" pitchFamily="49" charset="0"/>
-                <a:cs typeface="Courier New" panose="02070309020205020404" pitchFamily="49" charset="0"/>
-              </a:rPr>
-              <a:t>message</a:t>
-            </a:r>
-            <a:r>
-              <a:rPr lang="de-CH" sz="900" dirty="0">
-                <a:latin typeface="Courier New" panose="02070309020205020404" pitchFamily="49" charset="0"/>
-                <a:cs typeface="Courier New" panose="02070309020205020404" pitchFamily="49" charset="0"/>
-              </a:rPr>
-              <a:t>:</a:t>
-            </a:r>
-          </a:p>
-          <a:p>
-            <a:r>
-              <a:rPr lang="de-CH" sz="900" dirty="0">
-                <a:latin typeface="Courier New" panose="02070309020205020404" pitchFamily="49" charset="0"/>
-                <a:cs typeface="Courier New" panose="02070309020205020404" pitchFamily="49" charset="0"/>
-              </a:rPr>
-              <a:t>    +-- (</a:t>
-            </a:r>
-            <a:r>
-              <a:rPr lang="de-CH" sz="900" dirty="0" err="1">
-                <a:latin typeface="Courier New" panose="02070309020205020404" pitchFamily="49" charset="0"/>
-                <a:cs typeface="Courier New" panose="02070309020205020404" pitchFamily="49" charset="0"/>
-              </a:rPr>
-              <a:t>message</a:t>
-            </a:r>
-            <a:r>
-              <a:rPr lang="de-CH" sz="900" dirty="0">
-                <a:latin typeface="Courier New" panose="02070309020205020404" pitchFamily="49" charset="0"/>
-                <a:cs typeface="Courier New" panose="02070309020205020404" pitchFamily="49" charset="0"/>
-              </a:rPr>
-              <a:t>-type)?</a:t>
-            </a:r>
-          </a:p>
-          <a:p>
-            <a:r>
-              <a:rPr lang="de-CH" sz="900" dirty="0">
+              <a:rPr lang="en-US" sz="900" noProof="0" dirty="0">
+                <a:latin typeface="Courier New" panose="02070309020205020404" pitchFamily="49" charset="0"/>
+                <a:cs typeface="Courier New" panose="02070309020205020404" pitchFamily="49" charset="0"/>
+              </a:rPr>
+              <a:t>  structure message:</a:t>
+            </a:r>
+          </a:p>
+          <a:p>
+            <a:r>
+              <a:rPr lang="en-US" sz="900" noProof="0" dirty="0">
+                <a:latin typeface="Courier New" panose="02070309020205020404" pitchFamily="49" charset="0"/>
+                <a:cs typeface="Courier New" panose="02070309020205020404" pitchFamily="49" charset="0"/>
+              </a:rPr>
+              <a:t>    +-- (message-type)?</a:t>
+            </a:r>
+          </a:p>
+          <a:p>
+            <a:r>
+              <a:rPr lang="en-US" sz="900" noProof="0" dirty="0">
                 <a:latin typeface="Courier New" panose="02070309020205020404" pitchFamily="49" charset="0"/>
                 <a:cs typeface="Courier New" panose="02070309020205020404" pitchFamily="49" charset="0"/>
               </a:rPr>
@@ -11458,7 +11051,7 @@
           </a:p>
           <a:p>
             <a:r>
-              <a:rPr lang="de-CH" sz="900" dirty="0">
+              <a:rPr lang="en-US" sz="900" noProof="0" dirty="0">
                 <a:latin typeface="Courier New" panose="02070309020205020404" pitchFamily="49" charset="0"/>
                 <a:cs typeface="Courier New" panose="02070309020205020404" pitchFamily="49" charset="0"/>
               </a:rPr>
@@ -11467,477 +11060,301 @@
           </a:p>
           <a:p>
             <a:r>
-              <a:rPr lang="de-CH" sz="900" dirty="0">
+              <a:rPr lang="en-US" sz="900" noProof="0" dirty="0">
                 <a:latin typeface="Courier New" panose="02070309020205020404" pitchFamily="49" charset="0"/>
                 <a:cs typeface="Courier New" panose="02070309020205020404" pitchFamily="49" charset="0"/>
               </a:rPr>
               <a:t>       |     +-- peer-type             </a:t>
             </a:r>
             <a:r>
-              <a:rPr lang="de-CH" sz="900" dirty="0" err="1">
+              <a:rPr lang="en-US" sz="900" noProof="0" dirty="0" err="1">
                 <a:latin typeface="Courier New" panose="02070309020205020404" pitchFamily="49" charset="0"/>
                 <a:cs typeface="Courier New" panose="02070309020205020404" pitchFamily="49" charset="0"/>
               </a:rPr>
               <a:t>peer-type</a:t>
             </a:r>
-            <a:endParaRPr lang="de-CH" sz="900" dirty="0">
+            <a:endParaRPr lang="en-US" sz="900" noProof="0" dirty="0">
               <a:latin typeface="Courier New" panose="02070309020205020404" pitchFamily="49" charset="0"/>
               <a:cs typeface="Courier New" panose="02070309020205020404" pitchFamily="49" charset="0"/>
             </a:endParaRPr>
           </a:p>
           <a:p>
             <a:r>
-              <a:rPr lang="de-CH" sz="900" dirty="0">
-                <a:latin typeface="Courier New" panose="02070309020205020404" pitchFamily="49" charset="0"/>
-                <a:cs typeface="Courier New" panose="02070309020205020404" pitchFamily="49" charset="0"/>
-              </a:rPr>
-              <a:t>       |     +-- peer-</a:t>
-            </a:r>
-            <a:r>
-              <a:rPr lang="de-CH" sz="900" dirty="0" err="1">
-                <a:latin typeface="Courier New" panose="02070309020205020404" pitchFamily="49" charset="0"/>
-                <a:cs typeface="Courier New" panose="02070309020205020404" pitchFamily="49" charset="0"/>
-              </a:rPr>
-              <a:t>flags</a:t>
-            </a:r>
-            <a:endParaRPr lang="de-CH" sz="900" dirty="0">
+              <a:rPr lang="en-US" sz="900" noProof="0" dirty="0">
+                <a:latin typeface="Courier New" panose="02070309020205020404" pitchFamily="49" charset="0"/>
+                <a:cs typeface="Courier New" panose="02070309020205020404" pitchFamily="49" charset="0"/>
+              </a:rPr>
+              <a:t>       |     +-- peer-flags</a:t>
+            </a:r>
+          </a:p>
+          <a:p>
+            <a:r>
+              <a:rPr lang="en-US" sz="900" noProof="0" dirty="0">
+                <a:latin typeface="Courier New" panose="02070309020205020404" pitchFamily="49" charset="0"/>
+                <a:cs typeface="Courier New" panose="02070309020205020404" pitchFamily="49" charset="0"/>
+              </a:rPr>
+              <a:t>       |     |  +-- ipv6-peer?        </a:t>
+            </a:r>
+            <a:r>
+              <a:rPr lang="en-US" sz="900" noProof="0" dirty="0" err="1">
+                <a:latin typeface="Courier New" panose="02070309020205020404" pitchFamily="49" charset="0"/>
+                <a:cs typeface="Courier New" panose="02070309020205020404" pitchFamily="49" charset="0"/>
+              </a:rPr>
+              <a:t>boolean</a:t>
+            </a:r>
+            <a:endParaRPr lang="en-US" sz="900" noProof="0" dirty="0">
               <a:latin typeface="Courier New" panose="02070309020205020404" pitchFamily="49" charset="0"/>
               <a:cs typeface="Courier New" panose="02070309020205020404" pitchFamily="49" charset="0"/>
             </a:endParaRPr>
           </a:p>
           <a:p>
             <a:r>
-              <a:rPr lang="de-CH" sz="900" dirty="0">
-                <a:latin typeface="Courier New" panose="02070309020205020404" pitchFamily="49" charset="0"/>
-                <a:cs typeface="Courier New" panose="02070309020205020404" pitchFamily="49" charset="0"/>
-              </a:rPr>
-              <a:t>       |     |  +-- ipv6-peer?        </a:t>
-            </a:r>
-            <a:r>
-              <a:rPr lang="de-CH" sz="900" dirty="0" err="1">
+              <a:rPr lang="en-US" sz="900" noProof="0" dirty="0">
+                <a:latin typeface="Courier New" panose="02070309020205020404" pitchFamily="49" charset="0"/>
+                <a:cs typeface="Courier New" panose="02070309020205020404" pitchFamily="49" charset="0"/>
+              </a:rPr>
+              <a:t>       |     |  +-- post-policy?      </a:t>
+            </a:r>
+            <a:r>
+              <a:rPr lang="en-US" sz="900" noProof="0" dirty="0" err="1">
                 <a:latin typeface="Courier New" panose="02070309020205020404" pitchFamily="49" charset="0"/>
                 <a:cs typeface="Courier New" panose="02070309020205020404" pitchFamily="49" charset="0"/>
               </a:rPr>
               <a:t>boolean</a:t>
             </a:r>
-            <a:endParaRPr lang="de-CH" sz="900" dirty="0">
+            <a:endParaRPr lang="en-US" sz="900" noProof="0" dirty="0">
               <a:latin typeface="Courier New" panose="02070309020205020404" pitchFamily="49" charset="0"/>
               <a:cs typeface="Courier New" panose="02070309020205020404" pitchFamily="49" charset="0"/>
             </a:endParaRPr>
           </a:p>
           <a:p>
             <a:r>
-              <a:rPr lang="de-CH" sz="900" dirty="0">
-                <a:latin typeface="Courier New" panose="02070309020205020404" pitchFamily="49" charset="0"/>
-                <a:cs typeface="Courier New" panose="02070309020205020404" pitchFamily="49" charset="0"/>
-              </a:rPr>
-              <a:t>       |     |  +-- post-</a:t>
-            </a:r>
-            <a:r>
-              <a:rPr lang="de-CH" sz="900" dirty="0" err="1">
-                <a:latin typeface="Courier New" panose="02070309020205020404" pitchFamily="49" charset="0"/>
-                <a:cs typeface="Courier New" panose="02070309020205020404" pitchFamily="49" charset="0"/>
-              </a:rPr>
-              <a:t>policy</a:t>
-            </a:r>
-            <a:r>
-              <a:rPr lang="de-CH" sz="900" dirty="0">
-                <a:latin typeface="Courier New" panose="02070309020205020404" pitchFamily="49" charset="0"/>
-                <a:cs typeface="Courier New" panose="02070309020205020404" pitchFamily="49" charset="0"/>
-              </a:rPr>
-              <a:t>?      </a:t>
-            </a:r>
-            <a:r>
-              <a:rPr lang="de-CH" sz="900" dirty="0" err="1">
+              <a:rPr lang="en-US" sz="900" noProof="0" dirty="0">
+                <a:latin typeface="Courier New" panose="02070309020205020404" pitchFamily="49" charset="0"/>
+                <a:cs typeface="Courier New" panose="02070309020205020404" pitchFamily="49" charset="0"/>
+              </a:rPr>
+              <a:t>       |     |  +-- legacy-as-path?   </a:t>
+            </a:r>
+            <a:r>
+              <a:rPr lang="en-US" sz="900" noProof="0" dirty="0" err="1">
                 <a:latin typeface="Courier New" panose="02070309020205020404" pitchFamily="49" charset="0"/>
                 <a:cs typeface="Courier New" panose="02070309020205020404" pitchFamily="49" charset="0"/>
               </a:rPr>
               <a:t>boolean</a:t>
             </a:r>
-            <a:endParaRPr lang="de-CH" sz="900" dirty="0">
+            <a:endParaRPr lang="en-US" sz="900" noProof="0" dirty="0">
               <a:latin typeface="Courier New" panose="02070309020205020404" pitchFamily="49" charset="0"/>
               <a:cs typeface="Courier New" panose="02070309020205020404" pitchFamily="49" charset="0"/>
             </a:endParaRPr>
           </a:p>
           <a:p>
             <a:r>
-              <a:rPr lang="de-CH" sz="900" dirty="0">
-                <a:latin typeface="Courier New" panose="02070309020205020404" pitchFamily="49" charset="0"/>
-                <a:cs typeface="Courier New" panose="02070309020205020404" pitchFamily="49" charset="0"/>
-              </a:rPr>
-              <a:t>       |     |  +-- legacy-</a:t>
-            </a:r>
-            <a:r>
-              <a:rPr lang="de-CH" sz="900" dirty="0" err="1">
-                <a:latin typeface="Courier New" panose="02070309020205020404" pitchFamily="49" charset="0"/>
-                <a:cs typeface="Courier New" panose="02070309020205020404" pitchFamily="49" charset="0"/>
-              </a:rPr>
-              <a:t>as</a:t>
-            </a:r>
-            <a:r>
-              <a:rPr lang="de-CH" sz="900" dirty="0">
-                <a:latin typeface="Courier New" panose="02070309020205020404" pitchFamily="49" charset="0"/>
-                <a:cs typeface="Courier New" panose="02070309020205020404" pitchFamily="49" charset="0"/>
-              </a:rPr>
-              <a:t>-</a:t>
-            </a:r>
-            <a:r>
-              <a:rPr lang="de-CH" sz="900" dirty="0" err="1">
-                <a:latin typeface="Courier New" panose="02070309020205020404" pitchFamily="49" charset="0"/>
-                <a:cs typeface="Courier New" panose="02070309020205020404" pitchFamily="49" charset="0"/>
-              </a:rPr>
-              <a:t>path</a:t>
-            </a:r>
-            <a:r>
-              <a:rPr lang="de-CH" sz="900" dirty="0">
-                <a:latin typeface="Courier New" panose="02070309020205020404" pitchFamily="49" charset="0"/>
-                <a:cs typeface="Courier New" panose="02070309020205020404" pitchFamily="49" charset="0"/>
-              </a:rPr>
-              <a:t>?   </a:t>
-            </a:r>
-            <a:r>
-              <a:rPr lang="de-CH" sz="900" dirty="0" err="1">
+              <a:rPr lang="en-US" sz="900" noProof="0" dirty="0">
+                <a:latin typeface="Courier New" panose="02070309020205020404" pitchFamily="49" charset="0"/>
+                <a:cs typeface="Courier New" panose="02070309020205020404" pitchFamily="49" charset="0"/>
+              </a:rPr>
+              <a:t>       |     |  +-- adj-rib-out?      </a:t>
+            </a:r>
+            <a:r>
+              <a:rPr lang="en-US" sz="900" noProof="0" dirty="0" err="1">
                 <a:latin typeface="Courier New" panose="02070309020205020404" pitchFamily="49" charset="0"/>
                 <a:cs typeface="Courier New" panose="02070309020205020404" pitchFamily="49" charset="0"/>
               </a:rPr>
               <a:t>boolean</a:t>
             </a:r>
-            <a:endParaRPr lang="de-CH" sz="900" dirty="0">
+            <a:endParaRPr lang="en-US" sz="900" noProof="0" dirty="0">
               <a:latin typeface="Courier New" panose="02070309020205020404" pitchFamily="49" charset="0"/>
               <a:cs typeface="Courier New" panose="02070309020205020404" pitchFamily="49" charset="0"/>
             </a:endParaRPr>
           </a:p>
           <a:p>
             <a:r>
-              <a:rPr lang="de-CH" sz="900" dirty="0">
-                <a:latin typeface="Courier New" panose="02070309020205020404" pitchFamily="49" charset="0"/>
-                <a:cs typeface="Courier New" panose="02070309020205020404" pitchFamily="49" charset="0"/>
-              </a:rPr>
-              <a:t>       |     |  +-- </a:t>
-            </a:r>
-            <a:r>
-              <a:rPr lang="de-CH" sz="900" dirty="0" err="1">
-                <a:latin typeface="Courier New" panose="02070309020205020404" pitchFamily="49" charset="0"/>
-                <a:cs typeface="Courier New" panose="02070309020205020404" pitchFamily="49" charset="0"/>
-              </a:rPr>
-              <a:t>adj</a:t>
-            </a:r>
-            <a:r>
-              <a:rPr lang="de-CH" sz="900" dirty="0">
-                <a:latin typeface="Courier New" panose="02070309020205020404" pitchFamily="49" charset="0"/>
-                <a:cs typeface="Courier New" panose="02070309020205020404" pitchFamily="49" charset="0"/>
-              </a:rPr>
-              <a:t>-</a:t>
-            </a:r>
-            <a:r>
-              <a:rPr lang="de-CH" sz="900" dirty="0" err="1">
-                <a:latin typeface="Courier New" panose="02070309020205020404" pitchFamily="49" charset="0"/>
-                <a:cs typeface="Courier New" panose="02070309020205020404" pitchFamily="49" charset="0"/>
-              </a:rPr>
-              <a:t>rib</a:t>
-            </a:r>
-            <a:r>
-              <a:rPr lang="de-CH" sz="900" dirty="0">
-                <a:latin typeface="Courier New" panose="02070309020205020404" pitchFamily="49" charset="0"/>
-                <a:cs typeface="Courier New" panose="02070309020205020404" pitchFamily="49" charset="0"/>
-              </a:rPr>
-              <a:t>-out?      </a:t>
-            </a:r>
-            <a:r>
-              <a:rPr lang="de-CH" sz="900" dirty="0" err="1">
+              <a:rPr lang="en-US" sz="900" noProof="0" dirty="0">
+                <a:latin typeface="Courier New" panose="02070309020205020404" pitchFamily="49" charset="0"/>
+                <a:cs typeface="Courier New" panose="02070309020205020404" pitchFamily="49" charset="0"/>
+              </a:rPr>
+              <a:t>       |     |  +-- filtered?         </a:t>
+            </a:r>
+            <a:r>
+              <a:rPr lang="en-US" sz="900" noProof="0" dirty="0" err="1">
                 <a:latin typeface="Courier New" panose="02070309020205020404" pitchFamily="49" charset="0"/>
                 <a:cs typeface="Courier New" panose="02070309020205020404" pitchFamily="49" charset="0"/>
               </a:rPr>
               <a:t>boolean</a:t>
             </a:r>
-            <a:endParaRPr lang="de-CH" sz="900" dirty="0">
+            <a:endParaRPr lang="en-US" sz="900" noProof="0" dirty="0">
               <a:latin typeface="Courier New" panose="02070309020205020404" pitchFamily="49" charset="0"/>
               <a:cs typeface="Courier New" panose="02070309020205020404" pitchFamily="49" charset="0"/>
             </a:endParaRPr>
           </a:p>
           <a:p>
             <a:r>
-              <a:rPr lang="de-CH" sz="900" dirty="0">
-                <a:latin typeface="Courier New" panose="02070309020205020404" pitchFamily="49" charset="0"/>
-                <a:cs typeface="Courier New" panose="02070309020205020404" pitchFamily="49" charset="0"/>
-              </a:rPr>
-              <a:t>       |     |  +-- </a:t>
-            </a:r>
-            <a:r>
-              <a:rPr lang="de-CH" sz="900" dirty="0" err="1">
-                <a:latin typeface="Courier New" panose="02070309020205020404" pitchFamily="49" charset="0"/>
-                <a:cs typeface="Courier New" panose="02070309020205020404" pitchFamily="49" charset="0"/>
-              </a:rPr>
-              <a:t>filtered</a:t>
-            </a:r>
-            <a:r>
-              <a:rPr lang="de-CH" sz="900" dirty="0">
-                <a:latin typeface="Courier New" panose="02070309020205020404" pitchFamily="49" charset="0"/>
-                <a:cs typeface="Courier New" panose="02070309020205020404" pitchFamily="49" charset="0"/>
-              </a:rPr>
-              <a:t>?         </a:t>
-            </a:r>
-            <a:r>
-              <a:rPr lang="de-CH" sz="900" dirty="0" err="1">
-                <a:latin typeface="Courier New" panose="02070309020205020404" pitchFamily="49" charset="0"/>
-                <a:cs typeface="Courier New" panose="02070309020205020404" pitchFamily="49" charset="0"/>
-              </a:rPr>
-              <a:t>boolean</a:t>
-            </a:r>
-            <a:endParaRPr lang="de-CH" sz="900" dirty="0">
+              <a:rPr lang="en-US" sz="900" noProof="0" dirty="0">
+                <a:latin typeface="Courier New" panose="02070309020205020404" pitchFamily="49" charset="0"/>
+                <a:cs typeface="Courier New" panose="02070309020205020404" pitchFamily="49" charset="0"/>
+              </a:rPr>
+              <a:t>       |     +-- peer-distinguisher    </a:t>
+            </a:r>
+            <a:r>
+              <a:rPr lang="en-US" sz="900" noProof="0" dirty="0" err="1">
+                <a:latin typeface="Courier New" panose="02070309020205020404" pitchFamily="49" charset="0"/>
+                <a:cs typeface="Courier New" panose="02070309020205020404" pitchFamily="49" charset="0"/>
+              </a:rPr>
+              <a:t>rt-types:route-distinguisher</a:t>
+            </a:r>
+            <a:endParaRPr lang="en-US" sz="900" noProof="0" dirty="0">
               <a:latin typeface="Courier New" panose="02070309020205020404" pitchFamily="49" charset="0"/>
               <a:cs typeface="Courier New" panose="02070309020205020404" pitchFamily="49" charset="0"/>
             </a:endParaRPr>
           </a:p>
           <a:p>
             <a:r>
-              <a:rPr lang="de-CH" sz="900" dirty="0">
-                <a:latin typeface="Courier New" panose="02070309020205020404" pitchFamily="49" charset="0"/>
-                <a:cs typeface="Courier New" panose="02070309020205020404" pitchFamily="49" charset="0"/>
-              </a:rPr>
-              <a:t>       |     +-- peer-</a:t>
-            </a:r>
-            <a:r>
-              <a:rPr lang="de-CH" sz="900" dirty="0" err="1">
-                <a:latin typeface="Courier New" panose="02070309020205020404" pitchFamily="49" charset="0"/>
-                <a:cs typeface="Courier New" panose="02070309020205020404" pitchFamily="49" charset="0"/>
-              </a:rPr>
-              <a:t>distinguisher</a:t>
-            </a:r>
-            <a:r>
-              <a:rPr lang="de-CH" sz="900" dirty="0">
-                <a:latin typeface="Courier New" panose="02070309020205020404" pitchFamily="49" charset="0"/>
-                <a:cs typeface="Courier New" panose="02070309020205020404" pitchFamily="49" charset="0"/>
-              </a:rPr>
-              <a:t>    </a:t>
-            </a:r>
-            <a:r>
-              <a:rPr lang="de-CH" sz="900" dirty="0" err="1">
-                <a:latin typeface="Courier New" panose="02070309020205020404" pitchFamily="49" charset="0"/>
-                <a:cs typeface="Courier New" panose="02070309020205020404" pitchFamily="49" charset="0"/>
-              </a:rPr>
-              <a:t>rt-types:route-distinguisher</a:t>
-            </a:r>
-            <a:endParaRPr lang="de-CH" sz="900" dirty="0">
+              <a:rPr lang="en-US" sz="900" noProof="0" dirty="0">
+                <a:latin typeface="Courier New" panose="02070309020205020404" pitchFamily="49" charset="0"/>
+                <a:cs typeface="Courier New" panose="02070309020205020404" pitchFamily="49" charset="0"/>
+              </a:rPr>
+              <a:t>       |     +-- peer-address          </a:t>
+            </a:r>
+            <a:r>
+              <a:rPr lang="en-US" sz="900" noProof="0" dirty="0" err="1">
+                <a:latin typeface="Courier New" panose="02070309020205020404" pitchFamily="49" charset="0"/>
+                <a:cs typeface="Courier New" panose="02070309020205020404" pitchFamily="49" charset="0"/>
+              </a:rPr>
+              <a:t>inet:ip-address</a:t>
+            </a:r>
+            <a:endParaRPr lang="en-US" sz="900" noProof="0" dirty="0">
               <a:latin typeface="Courier New" panose="02070309020205020404" pitchFamily="49" charset="0"/>
               <a:cs typeface="Courier New" panose="02070309020205020404" pitchFamily="49" charset="0"/>
             </a:endParaRPr>
           </a:p>
           <a:p>
             <a:r>
-              <a:rPr lang="de-CH" sz="900" dirty="0">
+              <a:rPr lang="en-US" sz="900" noProof="0" dirty="0">
+                <a:latin typeface="Courier New" panose="02070309020205020404" pitchFamily="49" charset="0"/>
+                <a:cs typeface="Courier New" panose="02070309020205020404" pitchFamily="49" charset="0"/>
+              </a:rPr>
+              <a:t>       |     +-- peer-as               uint32</a:t>
+            </a:r>
+          </a:p>
+          <a:p>
+            <a:r>
+              <a:rPr lang="en-US" sz="900" noProof="0" dirty="0">
                 <a:latin typeface="Courier New" panose="02070309020205020404" pitchFamily="49" charset="0"/>
                 <a:cs typeface="Courier New" panose="02070309020205020404" pitchFamily="49" charset="0"/>
               </a:rPr>
               <a:t>       |     +-- peer-</a:t>
             </a:r>
             <a:r>
-              <a:rPr lang="de-CH" sz="900" dirty="0" err="1">
-                <a:latin typeface="Courier New" panose="02070309020205020404" pitchFamily="49" charset="0"/>
-                <a:cs typeface="Courier New" panose="02070309020205020404" pitchFamily="49" charset="0"/>
-              </a:rPr>
-              <a:t>address</a:t>
-            </a:r>
-            <a:r>
-              <a:rPr lang="de-CH" sz="900" dirty="0">
-                <a:latin typeface="Courier New" panose="02070309020205020404" pitchFamily="49" charset="0"/>
-                <a:cs typeface="Courier New" panose="02070309020205020404" pitchFamily="49" charset="0"/>
-              </a:rPr>
-              <a:t>          </a:t>
-            </a:r>
-            <a:r>
-              <a:rPr lang="de-CH" sz="900" dirty="0" err="1">
-                <a:latin typeface="Courier New" panose="02070309020205020404" pitchFamily="49" charset="0"/>
-                <a:cs typeface="Courier New" panose="02070309020205020404" pitchFamily="49" charset="0"/>
-              </a:rPr>
-              <a:t>inet:ip-address</a:t>
-            </a:r>
-            <a:endParaRPr lang="de-CH" sz="900" dirty="0">
+              <a:rPr lang="en-US" sz="900" noProof="0" dirty="0" err="1">
+                <a:latin typeface="Courier New" panose="02070309020205020404" pitchFamily="49" charset="0"/>
+                <a:cs typeface="Courier New" panose="02070309020205020404" pitchFamily="49" charset="0"/>
+              </a:rPr>
+              <a:t>bgp</a:t>
+            </a:r>
+            <a:r>
+              <a:rPr lang="en-US" sz="900" noProof="0" dirty="0">
+                <a:latin typeface="Courier New" panose="02070309020205020404" pitchFamily="49" charset="0"/>
+                <a:cs typeface="Courier New" panose="02070309020205020404" pitchFamily="49" charset="0"/>
+              </a:rPr>
+              <a:t>-id           inet:ipv4-address</a:t>
+            </a:r>
+          </a:p>
+          <a:p>
+            <a:r>
+              <a:rPr lang="en-US" sz="900" noProof="0" dirty="0">
+                <a:latin typeface="Courier New" panose="02070309020205020404" pitchFamily="49" charset="0"/>
+                <a:cs typeface="Courier New" panose="02070309020205020404" pitchFamily="49" charset="0"/>
+              </a:rPr>
+              <a:t>       |     +-- timestamp?            </a:t>
+            </a:r>
+            <a:r>
+              <a:rPr lang="en-US" sz="900" noProof="0" dirty="0" err="1">
+                <a:latin typeface="Courier New" panose="02070309020205020404" pitchFamily="49" charset="0"/>
+                <a:cs typeface="Courier New" panose="02070309020205020404" pitchFamily="49" charset="0"/>
+              </a:rPr>
+              <a:t>yang:date-and-time</a:t>
+            </a:r>
+            <a:endParaRPr lang="en-US" sz="900" noProof="0" dirty="0">
               <a:latin typeface="Courier New" panose="02070309020205020404" pitchFamily="49" charset="0"/>
               <a:cs typeface="Courier New" panose="02070309020205020404" pitchFamily="49" charset="0"/>
             </a:endParaRPr>
           </a:p>
           <a:p>
             <a:r>
-              <a:rPr lang="de-CH" sz="900" dirty="0">
-                <a:latin typeface="Courier New" panose="02070309020205020404" pitchFamily="49" charset="0"/>
-                <a:cs typeface="Courier New" panose="02070309020205020404" pitchFamily="49" charset="0"/>
-              </a:rPr>
-              <a:t>       |     +-- peer-</a:t>
-            </a:r>
-            <a:r>
-              <a:rPr lang="de-CH" sz="900" dirty="0" err="1">
-                <a:latin typeface="Courier New" panose="02070309020205020404" pitchFamily="49" charset="0"/>
-                <a:cs typeface="Courier New" panose="02070309020205020404" pitchFamily="49" charset="0"/>
-              </a:rPr>
-              <a:t>as</a:t>
-            </a:r>
-            <a:r>
-              <a:rPr lang="de-CH" sz="900" dirty="0">
-                <a:latin typeface="Courier New" panose="02070309020205020404" pitchFamily="49" charset="0"/>
-                <a:cs typeface="Courier New" panose="02070309020205020404" pitchFamily="49" charset="0"/>
-              </a:rPr>
-              <a:t>               uint32</a:t>
-            </a:r>
-          </a:p>
-          <a:p>
-            <a:r>
-              <a:rPr lang="de-CH" sz="900" dirty="0">
-                <a:latin typeface="Courier New" panose="02070309020205020404" pitchFamily="49" charset="0"/>
-                <a:cs typeface="Courier New" panose="02070309020205020404" pitchFamily="49" charset="0"/>
-              </a:rPr>
-              <a:t>       |     +-- peer-</a:t>
-            </a:r>
-            <a:r>
-              <a:rPr lang="de-CH" sz="900" dirty="0" err="1">
-                <a:latin typeface="Courier New" panose="02070309020205020404" pitchFamily="49" charset="0"/>
-                <a:cs typeface="Courier New" panose="02070309020205020404" pitchFamily="49" charset="0"/>
-              </a:rPr>
-              <a:t>bgp</a:t>
-            </a:r>
-            <a:r>
-              <a:rPr lang="de-CH" sz="900" dirty="0">
+              <a:rPr lang="en-US" sz="900" noProof="0" dirty="0">
+                <a:latin typeface="Courier New" panose="02070309020205020404" pitchFamily="49" charset="0"/>
+                <a:cs typeface="Courier New" panose="02070309020205020404" pitchFamily="49" charset="0"/>
+              </a:rPr>
+              <a:t>       |     +-- </a:t>
+            </a:r>
+            <a:r>
+              <a:rPr lang="en-US" sz="900" noProof="0" dirty="0" err="1">
+                <a:latin typeface="Courier New" panose="02070309020205020404" pitchFamily="49" charset="0"/>
+                <a:cs typeface="Courier New" panose="02070309020205020404" pitchFamily="49" charset="0"/>
+              </a:rPr>
+              <a:t>afi</a:t>
+            </a:r>
+            <a:r>
+              <a:rPr lang="en-US" sz="900" noProof="0" dirty="0">
                 <a:latin typeface="Courier New" panose="02070309020205020404" pitchFamily="49" charset="0"/>
                 <a:cs typeface="Courier New" panose="02070309020205020404" pitchFamily="49" charset="0"/>
               </a:rPr>
               <a:t>-</a:t>
             </a:r>
             <a:r>
-              <a:rPr lang="de-CH" sz="900" dirty="0" err="1">
-                <a:latin typeface="Courier New" panose="02070309020205020404" pitchFamily="49" charset="0"/>
-                <a:cs typeface="Courier New" panose="02070309020205020404" pitchFamily="49" charset="0"/>
-              </a:rPr>
-              <a:t>id</a:t>
-            </a:r>
-            <a:r>
-              <a:rPr lang="de-CH" sz="900" dirty="0">
-                <a:latin typeface="Courier New" panose="02070309020205020404" pitchFamily="49" charset="0"/>
-                <a:cs typeface="Courier New" panose="02070309020205020404" pitchFamily="49" charset="0"/>
-              </a:rPr>
-              <a:t>           inet:ipv4-address</a:t>
-            </a:r>
-          </a:p>
-          <a:p>
-            <a:r>
-              <a:rPr lang="de-CH" sz="900" dirty="0">
-                <a:latin typeface="Courier New" panose="02070309020205020404" pitchFamily="49" charset="0"/>
-                <a:cs typeface="Courier New" panose="02070309020205020404" pitchFamily="49" charset="0"/>
-              </a:rPr>
-              <a:t>       |     +-- </a:t>
-            </a:r>
-            <a:r>
-              <a:rPr lang="de-CH" sz="900" dirty="0" err="1">
-                <a:latin typeface="Courier New" panose="02070309020205020404" pitchFamily="49" charset="0"/>
-                <a:cs typeface="Courier New" panose="02070309020205020404" pitchFamily="49" charset="0"/>
-              </a:rPr>
-              <a:t>timestamp</a:t>
-            </a:r>
-            <a:r>
-              <a:rPr lang="de-CH" sz="900" dirty="0">
-                <a:latin typeface="Courier New" panose="02070309020205020404" pitchFamily="49" charset="0"/>
-                <a:cs typeface="Courier New" panose="02070309020205020404" pitchFamily="49" charset="0"/>
-              </a:rPr>
-              <a:t>?            </a:t>
-            </a:r>
-            <a:r>
-              <a:rPr lang="de-CH" sz="900" dirty="0" err="1">
-                <a:latin typeface="Courier New" panose="02070309020205020404" pitchFamily="49" charset="0"/>
-                <a:cs typeface="Courier New" panose="02070309020205020404" pitchFamily="49" charset="0"/>
-              </a:rPr>
-              <a:t>yang:date-and-time</a:t>
-            </a:r>
-            <a:endParaRPr lang="de-CH" sz="900" dirty="0">
+              <a:rPr lang="en-US" sz="900" noProof="0" dirty="0" err="1">
+                <a:latin typeface="Courier New" panose="02070309020205020404" pitchFamily="49" charset="0"/>
+                <a:cs typeface="Courier New" panose="02070309020205020404" pitchFamily="49" charset="0"/>
+              </a:rPr>
+              <a:t>safi</a:t>
+            </a:r>
+            <a:r>
+              <a:rPr lang="en-US" sz="900" noProof="0" dirty="0">
+                <a:latin typeface="Courier New" panose="02070309020205020404" pitchFamily="49" charset="0"/>
+                <a:cs typeface="Courier New" panose="02070309020205020404" pitchFamily="49" charset="0"/>
+              </a:rPr>
+              <a:t>-type         </a:t>
+            </a:r>
+            <a:r>
+              <a:rPr lang="en-US" sz="900" noProof="0" dirty="0" err="1">
+                <a:latin typeface="Courier New" panose="02070309020205020404" pitchFamily="49" charset="0"/>
+                <a:cs typeface="Courier New" panose="02070309020205020404" pitchFamily="49" charset="0"/>
+              </a:rPr>
+              <a:t>identityref</a:t>
+            </a:r>
+            <a:endParaRPr lang="en-US" sz="900" noProof="0" dirty="0">
               <a:latin typeface="Courier New" panose="02070309020205020404" pitchFamily="49" charset="0"/>
               <a:cs typeface="Courier New" panose="02070309020205020404" pitchFamily="49" charset="0"/>
             </a:endParaRPr>
           </a:p>
           <a:p>
             <a:r>
-              <a:rPr lang="de-CH" sz="900" dirty="0">
-                <a:latin typeface="Courier New" panose="02070309020205020404" pitchFamily="49" charset="0"/>
-                <a:cs typeface="Courier New" panose="02070309020205020404" pitchFamily="49" charset="0"/>
-              </a:rPr>
-              <a:t>       |     +-- </a:t>
-            </a:r>
-            <a:r>
-              <a:rPr lang="de-CH" sz="900" dirty="0" err="1">
-                <a:latin typeface="Courier New" panose="02070309020205020404" pitchFamily="49" charset="0"/>
-                <a:cs typeface="Courier New" panose="02070309020205020404" pitchFamily="49" charset="0"/>
-              </a:rPr>
-              <a:t>afi</a:t>
-            </a:r>
-            <a:r>
-              <a:rPr lang="de-CH" sz="900" dirty="0">
-                <a:latin typeface="Courier New" panose="02070309020205020404" pitchFamily="49" charset="0"/>
-                <a:cs typeface="Courier New" panose="02070309020205020404" pitchFamily="49" charset="0"/>
-              </a:rPr>
-              <a:t>-</a:t>
-            </a:r>
-            <a:r>
-              <a:rPr lang="de-CH" sz="900" dirty="0" err="1">
-                <a:latin typeface="Courier New" panose="02070309020205020404" pitchFamily="49" charset="0"/>
-                <a:cs typeface="Courier New" panose="02070309020205020404" pitchFamily="49" charset="0"/>
-              </a:rPr>
-              <a:t>safi</a:t>
-            </a:r>
-            <a:r>
-              <a:rPr lang="de-CH" sz="900" dirty="0">
-                <a:latin typeface="Courier New" panose="02070309020205020404" pitchFamily="49" charset="0"/>
-                <a:cs typeface="Courier New" panose="02070309020205020404" pitchFamily="49" charset="0"/>
-              </a:rPr>
-              <a:t>-type         </a:t>
-            </a:r>
-            <a:r>
-              <a:rPr lang="de-CH" sz="900" dirty="0" err="1">
-                <a:latin typeface="Courier New" panose="02070309020205020404" pitchFamily="49" charset="0"/>
-                <a:cs typeface="Courier New" panose="02070309020205020404" pitchFamily="49" charset="0"/>
-              </a:rPr>
-              <a:t>identityref</a:t>
-            </a:r>
-            <a:endParaRPr lang="de-CH" sz="900" dirty="0">
+              <a:rPr lang="en-US" sz="900" noProof="0" dirty="0">
+                <a:latin typeface="Courier New" panose="02070309020205020404" pitchFamily="49" charset="0"/>
+                <a:cs typeface="Courier New" panose="02070309020205020404" pitchFamily="49" charset="0"/>
+              </a:rPr>
+              <a:t>       |     +-- rib-entry</a:t>
+            </a:r>
+          </a:p>
+          <a:p>
+            <a:endParaRPr lang="en-US" sz="900" noProof="0" dirty="0">
               <a:latin typeface="Courier New" panose="02070309020205020404" pitchFamily="49" charset="0"/>
               <a:cs typeface="Courier New" panose="02070309020205020404" pitchFamily="49" charset="0"/>
             </a:endParaRPr>
           </a:p>
           <a:p>
             <a:r>
-              <a:rPr lang="de-CH" sz="900" dirty="0">
+              <a:rPr lang="en-US" sz="900" noProof="0" dirty="0">
+                <a:highlight>
+                  <a:srgbClr val="FFFF00"/>
+                </a:highlight>
                 <a:latin typeface="Courier New" panose="02070309020205020404" pitchFamily="49" charset="0"/>
                 <a:cs typeface="Courier New" panose="02070309020205020404" pitchFamily="49" charset="0"/>
               </a:rPr>
               <a:t>       |     +-- </a:t>
             </a:r>
             <a:r>
-              <a:rPr lang="de-CH" sz="900" dirty="0" err="1">
-                <a:latin typeface="Courier New" panose="02070309020205020404" pitchFamily="49" charset="0"/>
-                <a:cs typeface="Courier New" panose="02070309020205020404" pitchFamily="49" charset="0"/>
-              </a:rPr>
-              <a:t>rib-entry</a:t>
-            </a:r>
-            <a:endParaRPr lang="de-CH" sz="900" dirty="0">
-              <a:latin typeface="Courier New" panose="02070309020205020404" pitchFamily="49" charset="0"/>
-              <a:cs typeface="Courier New" panose="02070309020205020404" pitchFamily="49" charset="0"/>
-            </a:endParaRPr>
-          </a:p>
-          <a:p>
-            <a:endParaRPr lang="de-CH" sz="900" dirty="0">
-              <a:latin typeface="Courier New" panose="02070309020205020404" pitchFamily="49" charset="0"/>
-              <a:cs typeface="Courier New" panose="02070309020205020404" pitchFamily="49" charset="0"/>
-            </a:endParaRPr>
-          </a:p>
-          <a:p>
-            <a:r>
-              <a:rPr lang="de-CH" sz="900" dirty="0">
-                <a:highlight>
-                  <a:srgbClr val="FFFF00"/>
-                </a:highlight>
-                <a:latin typeface="Courier New" panose="02070309020205020404" pitchFamily="49" charset="0"/>
-                <a:cs typeface="Courier New" panose="02070309020205020404" pitchFamily="49" charset="0"/>
-              </a:rPr>
-              <a:t>       |     +-- </a:t>
-            </a:r>
-            <a:r>
-              <a:rPr lang="de-CH" sz="900" dirty="0" err="1">
+              <a:rPr lang="en-US" sz="900" noProof="0" dirty="0" err="1">
                 <a:highlight>
                   <a:srgbClr val="FFFF00"/>
                 </a:highlight>
@@ -11947,46 +11364,62 @@
               <a:t>vrf</a:t>
             </a:r>
             <a:r>
-              <a:rPr lang="de-CH" sz="900" dirty="0">
-                <a:highlight>
-                  <a:srgbClr val="FFFF00"/>
-                </a:highlight>
-                <a:latin typeface="Courier New" panose="02070309020205020404" pitchFamily="49" charset="0"/>
-                <a:cs typeface="Courier New" panose="02070309020205020404" pitchFamily="49" charset="0"/>
-              </a:rPr>
-              <a:t>-</a:t>
-            </a:r>
-            <a:r>
-              <a:rPr lang="de-CH" sz="900" dirty="0" err="1">
-                <a:highlight>
-                  <a:srgbClr val="FFFF00"/>
-                </a:highlight>
-                <a:latin typeface="Courier New" panose="02070309020205020404" pitchFamily="49" charset="0"/>
-                <a:cs typeface="Courier New" panose="02070309020205020404" pitchFamily="49" charset="0"/>
-              </a:rPr>
-              <a:t>table</a:t>
-            </a:r>
-            <a:r>
-              <a:rPr lang="de-CH" sz="900" dirty="0">
-                <a:highlight>
-                  <a:srgbClr val="FFFF00"/>
-                </a:highlight>
-                <a:latin typeface="Courier New" panose="02070309020205020404" pitchFamily="49" charset="0"/>
-                <a:cs typeface="Courier New" panose="02070309020205020404" pitchFamily="49" charset="0"/>
-              </a:rPr>
-              <a:t>-name?       </a:t>
-            </a:r>
-            <a:r>
-              <a:rPr lang="de-CH" sz="900" dirty="0" err="1">
-                <a:highlight>
-                  <a:srgbClr val="FFFF00"/>
-                </a:highlight>
-                <a:latin typeface="Courier New" panose="02070309020205020404" pitchFamily="49" charset="0"/>
-                <a:cs typeface="Courier New" panose="02070309020205020404" pitchFamily="49" charset="0"/>
-              </a:rPr>
-              <a:t>string</a:t>
-            </a:r>
-            <a:endParaRPr lang="de-CH" sz="900" dirty="0">
+              <a:rPr lang="en-US" sz="900" noProof="0" dirty="0">
+                <a:highlight>
+                  <a:srgbClr val="FFFF00"/>
+                </a:highlight>
+                <a:latin typeface="Courier New" panose="02070309020205020404" pitchFamily="49" charset="0"/>
+                <a:cs typeface="Courier New" panose="02070309020205020404" pitchFamily="49" charset="0"/>
+              </a:rPr>
+              <a:t>-table-name?       string</a:t>
+            </a:r>
+          </a:p>
+          <a:p>
+            <a:r>
+              <a:rPr lang="en-US" sz="900" noProof="0" dirty="0">
+                <a:highlight>
+                  <a:srgbClr val="FFFF00"/>
+                </a:highlight>
+                <a:latin typeface="Courier New" panose="02070309020205020404" pitchFamily="49" charset="0"/>
+                <a:cs typeface="Courier New" panose="02070309020205020404" pitchFamily="49" charset="0"/>
+              </a:rPr>
+              <a:t>       |     +-- sequence-number?      uint64</a:t>
+            </a:r>
+          </a:p>
+          <a:p>
+            <a:r>
+              <a:rPr lang="en-US" sz="900" noProof="0" dirty="0">
+                <a:highlight>
+                  <a:srgbClr val="FFFF00"/>
+                </a:highlight>
+                <a:latin typeface="Courier New" panose="02070309020205020404" pitchFamily="49" charset="0"/>
+                <a:cs typeface="Courier New" panose="02070309020205020404" pitchFamily="49" charset="0"/>
+              </a:rPr>
+              <a:t>       |     +-- timestamps* [timestamp-type]</a:t>
+            </a:r>
+          </a:p>
+          <a:p>
+            <a:r>
+              <a:rPr lang="en-US" sz="900" noProof="0" dirty="0">
+                <a:highlight>
+                  <a:srgbClr val="FFFF00"/>
+                </a:highlight>
+                <a:latin typeface="Courier New" panose="02070309020205020404" pitchFamily="49" charset="0"/>
+                <a:cs typeface="Courier New" panose="02070309020205020404" pitchFamily="49" charset="0"/>
+              </a:rPr>
+              <a:t>       |     |  +-- timestamp-type    </a:t>
+            </a:r>
+            <a:r>
+              <a:rPr lang="en-US" sz="900" noProof="0" dirty="0" err="1">
+                <a:highlight>
+                  <a:srgbClr val="FFFF00"/>
+                </a:highlight>
+                <a:latin typeface="Courier New" panose="02070309020205020404" pitchFamily="49" charset="0"/>
+                <a:cs typeface="Courier New" panose="02070309020205020404" pitchFamily="49" charset="0"/>
+              </a:rPr>
+              <a:t>timestamp-type</a:t>
+            </a:r>
+            <a:endParaRPr lang="en-US" sz="900" noProof="0" dirty="0">
               <a:highlight>
                 <a:srgbClr val="FFFF00"/>
               </a:highlight>
@@ -11996,173 +11429,17 @@
           </a:p>
           <a:p>
             <a:r>
-              <a:rPr lang="de-CH" sz="900" dirty="0">
-                <a:highlight>
-                  <a:srgbClr val="FFFF00"/>
-                </a:highlight>
-                <a:latin typeface="Courier New" panose="02070309020205020404" pitchFamily="49" charset="0"/>
-                <a:cs typeface="Courier New" panose="02070309020205020404" pitchFamily="49" charset="0"/>
-              </a:rPr>
-              <a:t>       |     +-- </a:t>
-            </a:r>
-            <a:r>
-              <a:rPr lang="de-CH" sz="900" dirty="0" err="1">
-                <a:highlight>
-                  <a:srgbClr val="FFFF00"/>
-                </a:highlight>
-                <a:latin typeface="Courier New" panose="02070309020205020404" pitchFamily="49" charset="0"/>
-                <a:cs typeface="Courier New" panose="02070309020205020404" pitchFamily="49" charset="0"/>
-              </a:rPr>
-              <a:t>sequence-number</a:t>
-            </a:r>
-            <a:r>
-              <a:rPr lang="de-CH" sz="900" dirty="0">
-                <a:highlight>
-                  <a:srgbClr val="FFFF00"/>
-                </a:highlight>
-                <a:latin typeface="Courier New" panose="02070309020205020404" pitchFamily="49" charset="0"/>
-                <a:cs typeface="Courier New" panose="02070309020205020404" pitchFamily="49" charset="0"/>
-              </a:rPr>
-              <a:t>?      uint64</a:t>
-            </a:r>
-          </a:p>
-          <a:p>
-            <a:r>
-              <a:rPr lang="de-CH" sz="900" dirty="0">
-                <a:highlight>
-                  <a:srgbClr val="FFFF00"/>
-                </a:highlight>
-                <a:latin typeface="Courier New" panose="02070309020205020404" pitchFamily="49" charset="0"/>
-                <a:cs typeface="Courier New" panose="02070309020205020404" pitchFamily="49" charset="0"/>
-              </a:rPr>
-              <a:t>       |     +-- </a:t>
-            </a:r>
-            <a:r>
-              <a:rPr lang="de-CH" sz="900" dirty="0" err="1">
-                <a:highlight>
-                  <a:srgbClr val="FFFF00"/>
-                </a:highlight>
-                <a:latin typeface="Courier New" panose="02070309020205020404" pitchFamily="49" charset="0"/>
-                <a:cs typeface="Courier New" panose="02070309020205020404" pitchFamily="49" charset="0"/>
-              </a:rPr>
-              <a:t>timestamps</a:t>
-            </a:r>
-            <a:r>
-              <a:rPr lang="de-CH" sz="900" dirty="0">
-                <a:highlight>
-                  <a:srgbClr val="FFFF00"/>
-                </a:highlight>
-                <a:latin typeface="Courier New" panose="02070309020205020404" pitchFamily="49" charset="0"/>
-                <a:cs typeface="Courier New" panose="02070309020205020404" pitchFamily="49" charset="0"/>
-              </a:rPr>
-              <a:t>* [</a:t>
-            </a:r>
-            <a:r>
-              <a:rPr lang="de-CH" sz="900" dirty="0" err="1">
-                <a:highlight>
-                  <a:srgbClr val="FFFF00"/>
-                </a:highlight>
-                <a:latin typeface="Courier New" panose="02070309020205020404" pitchFamily="49" charset="0"/>
-                <a:cs typeface="Courier New" panose="02070309020205020404" pitchFamily="49" charset="0"/>
-              </a:rPr>
-              <a:t>timestamp</a:t>
-            </a:r>
-            <a:r>
-              <a:rPr lang="de-CH" sz="900" dirty="0">
-                <a:highlight>
-                  <a:srgbClr val="FFFF00"/>
-                </a:highlight>
-                <a:latin typeface="Courier New" panose="02070309020205020404" pitchFamily="49" charset="0"/>
-                <a:cs typeface="Courier New" panose="02070309020205020404" pitchFamily="49" charset="0"/>
-              </a:rPr>
-              <a:t>-type]</a:t>
-            </a:r>
-          </a:p>
-          <a:p>
-            <a:r>
-              <a:rPr lang="de-CH" sz="900" dirty="0">
-                <a:highlight>
-                  <a:srgbClr val="FFFF00"/>
-                </a:highlight>
-                <a:latin typeface="Courier New" panose="02070309020205020404" pitchFamily="49" charset="0"/>
-                <a:cs typeface="Courier New" panose="02070309020205020404" pitchFamily="49" charset="0"/>
-              </a:rPr>
-              <a:t>       |     |  +-- </a:t>
-            </a:r>
-            <a:r>
-              <a:rPr lang="de-CH" sz="900" dirty="0" err="1">
-                <a:highlight>
-                  <a:srgbClr val="FFFF00"/>
-                </a:highlight>
-                <a:latin typeface="Courier New" panose="02070309020205020404" pitchFamily="49" charset="0"/>
-                <a:cs typeface="Courier New" panose="02070309020205020404" pitchFamily="49" charset="0"/>
-              </a:rPr>
-              <a:t>timestamp</a:t>
-            </a:r>
-            <a:r>
-              <a:rPr lang="de-CH" sz="900" dirty="0">
-                <a:highlight>
-                  <a:srgbClr val="FFFF00"/>
-                </a:highlight>
-                <a:latin typeface="Courier New" panose="02070309020205020404" pitchFamily="49" charset="0"/>
-                <a:cs typeface="Courier New" panose="02070309020205020404" pitchFamily="49" charset="0"/>
-              </a:rPr>
-              <a:t>-type    </a:t>
-            </a:r>
-            <a:r>
-              <a:rPr lang="de-CH" sz="900" dirty="0" err="1">
-                <a:highlight>
-                  <a:srgbClr val="FFFF00"/>
-                </a:highlight>
-                <a:latin typeface="Courier New" panose="02070309020205020404" pitchFamily="49" charset="0"/>
-                <a:cs typeface="Courier New" panose="02070309020205020404" pitchFamily="49" charset="0"/>
-              </a:rPr>
-              <a:t>timestamp</a:t>
-            </a:r>
-            <a:r>
-              <a:rPr lang="de-CH" sz="900" dirty="0">
-                <a:highlight>
-                  <a:srgbClr val="FFFF00"/>
-                </a:highlight>
-                <a:latin typeface="Courier New" panose="02070309020205020404" pitchFamily="49" charset="0"/>
-                <a:cs typeface="Courier New" panose="02070309020205020404" pitchFamily="49" charset="0"/>
-              </a:rPr>
-              <a:t>-type</a:t>
-            </a:r>
-          </a:p>
-          <a:p>
-            <a:r>
-              <a:rPr lang="de-CH" sz="900" dirty="0">
-                <a:highlight>
-                  <a:srgbClr val="FFFF00"/>
-                </a:highlight>
-                <a:latin typeface="Courier New" panose="02070309020205020404" pitchFamily="49" charset="0"/>
-                <a:cs typeface="Courier New" panose="02070309020205020404" pitchFamily="49" charset="0"/>
-              </a:rPr>
-              <a:t>       |     |  +-- </a:t>
-            </a:r>
-            <a:r>
-              <a:rPr lang="de-CH" sz="900" dirty="0" err="1">
-                <a:highlight>
-                  <a:srgbClr val="FFFF00"/>
-                </a:highlight>
-                <a:latin typeface="Courier New" panose="02070309020205020404" pitchFamily="49" charset="0"/>
-                <a:cs typeface="Courier New" panose="02070309020205020404" pitchFamily="49" charset="0"/>
-              </a:rPr>
-              <a:t>timestamp</a:t>
-            </a:r>
-            <a:r>
-              <a:rPr lang="de-CH" sz="900" dirty="0">
-                <a:highlight>
-                  <a:srgbClr val="FFFF00"/>
-                </a:highlight>
-                <a:latin typeface="Courier New" panose="02070309020205020404" pitchFamily="49" charset="0"/>
-                <a:cs typeface="Courier New" panose="02070309020205020404" pitchFamily="49" charset="0"/>
-              </a:rPr>
-              <a:t>         </a:t>
-            </a:r>
-            <a:r>
-              <a:rPr lang="de-CH" sz="900" dirty="0" err="1">
+              <a:rPr lang="en-US" sz="900" noProof="0" dirty="0">
+                <a:highlight>
+                  <a:srgbClr val="FFFF00"/>
+                </a:highlight>
+                <a:latin typeface="Courier New" panose="02070309020205020404" pitchFamily="49" charset="0"/>
+                <a:cs typeface="Courier New" panose="02070309020205020404" pitchFamily="49" charset="0"/>
+              </a:rPr>
+              <a:t>       |     |  +-- timestamp         </a:t>
+            </a:r>
+            <a:r>
+              <a:rPr lang="en-US" sz="900" noProof="0" dirty="0" err="1">
                 <a:highlight>
                   <a:srgbClr val="FFFF00"/>
                 </a:highlight>
@@ -12171,7 +11448,7 @@
               </a:rPr>
               <a:t>yang:date-and-time</a:t>
             </a:r>
-            <a:endParaRPr lang="de-CH" sz="900" dirty="0">
+            <a:endParaRPr lang="en-US" sz="900" noProof="0" dirty="0">
               <a:highlight>
                 <a:srgbClr val="FFFF00"/>
               </a:highlight>
@@ -12181,39 +11458,19 @@
           </a:p>
           <a:p>
             <a:r>
-              <a:rPr lang="de-CH" sz="900" dirty="0">
-                <a:highlight>
-                  <a:srgbClr val="FFFF00"/>
-                </a:highlight>
-                <a:latin typeface="Courier New" panose="02070309020205020404" pitchFamily="49" charset="0"/>
-                <a:cs typeface="Courier New" panose="02070309020205020404" pitchFamily="49" charset="0"/>
-              </a:rPr>
-              <a:t>       |     +-- </a:t>
-            </a:r>
-            <a:r>
-              <a:rPr lang="de-CH" sz="900" dirty="0" err="1">
-                <a:highlight>
-                  <a:srgbClr val="FFFF00"/>
-                </a:highlight>
-                <a:latin typeface="Courier New" panose="02070309020205020404" pitchFamily="49" charset="0"/>
-                <a:cs typeface="Courier New" panose="02070309020205020404" pitchFamily="49" charset="0"/>
-              </a:rPr>
-              <a:t>extended-flags</a:t>
-            </a:r>
-            <a:r>
-              <a:rPr lang="de-CH" sz="900" dirty="0">
-                <a:highlight>
-                  <a:srgbClr val="FFFF00"/>
-                </a:highlight>
-                <a:latin typeface="Courier New" panose="02070309020205020404" pitchFamily="49" charset="0"/>
-                <a:cs typeface="Courier New" panose="02070309020205020404" pitchFamily="49" charset="0"/>
-              </a:rPr>
-              <a:t>!</a:t>
-            </a:r>
-          </a:p>
-          <a:p>
-            <a:r>
-              <a:rPr lang="de-CH" sz="900" dirty="0">
+              <a:rPr lang="en-US" sz="900" noProof="0" dirty="0">
+                <a:highlight>
+                  <a:srgbClr val="FFFF00"/>
+                </a:highlight>
+                <a:latin typeface="Courier New" panose="02070309020205020404" pitchFamily="49" charset="0"/>
+                <a:cs typeface="Courier New" panose="02070309020205020404" pitchFamily="49" charset="0"/>
+              </a:rPr>
+              <a:t>       |     +-- extended-flags!</a:t>
+            </a:r>
+          </a:p>
+          <a:p>
+            <a:r>
+              <a:rPr lang="en-US" sz="900" noProof="0" dirty="0">
                 <a:highlight>
                   <a:srgbClr val="FFFF00"/>
                 </a:highlight>
@@ -12223,7 +11480,7 @@
               <a:t>       |        +-- ipv6-peer?        </a:t>
             </a:r>
             <a:r>
-              <a:rPr lang="de-CH" sz="900" dirty="0" err="1">
+              <a:rPr lang="en-US" sz="900" noProof="0" dirty="0" err="1">
                 <a:highlight>
                   <a:srgbClr val="FFFF00"/>
                 </a:highlight>
@@ -12232,7 +11489,7 @@
               </a:rPr>
               <a:t>boolean</a:t>
             </a:r>
-            <a:endParaRPr lang="de-CH" sz="900" dirty="0">
+            <a:endParaRPr lang="en-US" sz="900" noProof="0" dirty="0">
               <a:highlight>
                 <a:srgbClr val="FFFF00"/>
               </a:highlight>
@@ -12242,37 +11499,17 @@
           </a:p>
           <a:p>
             <a:r>
-              <a:rPr lang="de-CH" sz="900" dirty="0">
-                <a:highlight>
-                  <a:srgbClr val="FFFF00"/>
-                </a:highlight>
-                <a:latin typeface="Courier New" panose="02070309020205020404" pitchFamily="49" charset="0"/>
-                <a:cs typeface="Courier New" panose="02070309020205020404" pitchFamily="49" charset="0"/>
-              </a:rPr>
-              <a:t>       |        +-- post-</a:t>
-            </a:r>
-            <a:r>
-              <a:rPr lang="de-CH" sz="900" dirty="0" err="1">
-                <a:highlight>
-                  <a:srgbClr val="FFFF00"/>
-                </a:highlight>
-                <a:latin typeface="Courier New" panose="02070309020205020404" pitchFamily="49" charset="0"/>
-                <a:cs typeface="Courier New" panose="02070309020205020404" pitchFamily="49" charset="0"/>
-              </a:rPr>
-              <a:t>policy</a:t>
-            </a:r>
-            <a:r>
-              <a:rPr lang="de-CH" sz="900" dirty="0">
-                <a:highlight>
-                  <a:srgbClr val="FFFF00"/>
-                </a:highlight>
-                <a:latin typeface="Courier New" panose="02070309020205020404" pitchFamily="49" charset="0"/>
-                <a:cs typeface="Courier New" panose="02070309020205020404" pitchFamily="49" charset="0"/>
-              </a:rPr>
-              <a:t>?      </a:t>
-            </a:r>
-            <a:r>
-              <a:rPr lang="de-CH" sz="900" dirty="0" err="1">
+              <a:rPr lang="en-US" sz="900" noProof="0" dirty="0">
+                <a:highlight>
+                  <a:srgbClr val="FFFF00"/>
+                </a:highlight>
+                <a:latin typeface="Courier New" panose="02070309020205020404" pitchFamily="49" charset="0"/>
+                <a:cs typeface="Courier New" panose="02070309020205020404" pitchFamily="49" charset="0"/>
+              </a:rPr>
+              <a:t>       |        +-- post-policy?      </a:t>
+            </a:r>
+            <a:r>
+              <a:rPr lang="en-US" sz="900" noProof="0" dirty="0" err="1">
                 <a:highlight>
                   <a:srgbClr val="FFFF00"/>
                 </a:highlight>
@@ -12281,7 +11518,7 @@
               </a:rPr>
               <a:t>boolean</a:t>
             </a:r>
-            <a:endParaRPr lang="de-CH" sz="900" dirty="0">
+            <a:endParaRPr lang="en-US" sz="900" noProof="0" dirty="0">
               <a:highlight>
                 <a:srgbClr val="FFFF00"/>
               </a:highlight>
@@ -12291,57 +11528,17 @@
           </a:p>
           <a:p>
             <a:r>
-              <a:rPr lang="de-CH" sz="900" dirty="0">
-                <a:highlight>
-                  <a:srgbClr val="FFFF00"/>
-                </a:highlight>
-                <a:latin typeface="Courier New" panose="02070309020205020404" pitchFamily="49" charset="0"/>
-                <a:cs typeface="Courier New" panose="02070309020205020404" pitchFamily="49" charset="0"/>
-              </a:rPr>
-              <a:t>       |        +-- legacy-</a:t>
-            </a:r>
-            <a:r>
-              <a:rPr lang="de-CH" sz="900" dirty="0" err="1">
-                <a:highlight>
-                  <a:srgbClr val="FFFF00"/>
-                </a:highlight>
-                <a:latin typeface="Courier New" panose="02070309020205020404" pitchFamily="49" charset="0"/>
-                <a:cs typeface="Courier New" panose="02070309020205020404" pitchFamily="49" charset="0"/>
-              </a:rPr>
-              <a:t>as</a:t>
-            </a:r>
-            <a:r>
-              <a:rPr lang="de-CH" sz="900" dirty="0">
-                <a:highlight>
-                  <a:srgbClr val="FFFF00"/>
-                </a:highlight>
-                <a:latin typeface="Courier New" panose="02070309020205020404" pitchFamily="49" charset="0"/>
-                <a:cs typeface="Courier New" panose="02070309020205020404" pitchFamily="49" charset="0"/>
-              </a:rPr>
-              <a:t>-</a:t>
-            </a:r>
-            <a:r>
-              <a:rPr lang="de-CH" sz="900" dirty="0" err="1">
-                <a:highlight>
-                  <a:srgbClr val="FFFF00"/>
-                </a:highlight>
-                <a:latin typeface="Courier New" panose="02070309020205020404" pitchFamily="49" charset="0"/>
-                <a:cs typeface="Courier New" panose="02070309020205020404" pitchFamily="49" charset="0"/>
-              </a:rPr>
-              <a:t>path</a:t>
-            </a:r>
-            <a:r>
-              <a:rPr lang="de-CH" sz="900" dirty="0">
-                <a:highlight>
-                  <a:srgbClr val="FFFF00"/>
-                </a:highlight>
-                <a:latin typeface="Courier New" panose="02070309020205020404" pitchFamily="49" charset="0"/>
-                <a:cs typeface="Courier New" panose="02070309020205020404" pitchFamily="49" charset="0"/>
-              </a:rPr>
-              <a:t>?   </a:t>
-            </a:r>
-            <a:r>
-              <a:rPr lang="de-CH" sz="900" dirty="0" err="1">
+              <a:rPr lang="en-US" sz="900" noProof="0" dirty="0">
+                <a:highlight>
+                  <a:srgbClr val="FFFF00"/>
+                </a:highlight>
+                <a:latin typeface="Courier New" panose="02070309020205020404" pitchFamily="49" charset="0"/>
+                <a:cs typeface="Courier New" panose="02070309020205020404" pitchFamily="49" charset="0"/>
+              </a:rPr>
+              <a:t>       |        +-- legacy-as-path?   </a:t>
+            </a:r>
+            <a:r>
+              <a:rPr lang="en-US" sz="900" noProof="0" dirty="0" err="1">
                 <a:highlight>
                   <a:srgbClr val="FFFF00"/>
                 </a:highlight>
@@ -12350,7 +11547,7 @@
               </a:rPr>
               <a:t>boolean</a:t>
             </a:r>
-            <a:endParaRPr lang="de-CH" sz="900" dirty="0">
+            <a:endParaRPr lang="en-US" sz="900" noProof="0" dirty="0">
               <a:highlight>
                 <a:srgbClr val="FFFF00"/>
               </a:highlight>
@@ -12360,57 +11557,17 @@
           </a:p>
           <a:p>
             <a:r>
-              <a:rPr lang="de-CH" sz="900" dirty="0">
-                <a:highlight>
-                  <a:srgbClr val="FFFF00"/>
-                </a:highlight>
-                <a:latin typeface="Courier New" panose="02070309020205020404" pitchFamily="49" charset="0"/>
-                <a:cs typeface="Courier New" panose="02070309020205020404" pitchFamily="49" charset="0"/>
-              </a:rPr>
-              <a:t>       |        +-- </a:t>
-            </a:r>
-            <a:r>
-              <a:rPr lang="de-CH" sz="900" dirty="0" err="1">
-                <a:highlight>
-                  <a:srgbClr val="FFFF00"/>
-                </a:highlight>
-                <a:latin typeface="Courier New" panose="02070309020205020404" pitchFamily="49" charset="0"/>
-                <a:cs typeface="Courier New" panose="02070309020205020404" pitchFamily="49" charset="0"/>
-              </a:rPr>
-              <a:t>adj</a:t>
-            </a:r>
-            <a:r>
-              <a:rPr lang="de-CH" sz="900" dirty="0">
-                <a:highlight>
-                  <a:srgbClr val="FFFF00"/>
-                </a:highlight>
-                <a:latin typeface="Courier New" panose="02070309020205020404" pitchFamily="49" charset="0"/>
-                <a:cs typeface="Courier New" panose="02070309020205020404" pitchFamily="49" charset="0"/>
-              </a:rPr>
-              <a:t>-</a:t>
-            </a:r>
-            <a:r>
-              <a:rPr lang="de-CH" sz="900" dirty="0" err="1">
-                <a:highlight>
-                  <a:srgbClr val="FFFF00"/>
-                </a:highlight>
-                <a:latin typeface="Courier New" panose="02070309020205020404" pitchFamily="49" charset="0"/>
-                <a:cs typeface="Courier New" panose="02070309020205020404" pitchFamily="49" charset="0"/>
-              </a:rPr>
-              <a:t>rib</a:t>
-            </a:r>
-            <a:r>
-              <a:rPr lang="de-CH" sz="900" dirty="0">
-                <a:highlight>
-                  <a:srgbClr val="FFFF00"/>
-                </a:highlight>
-                <a:latin typeface="Courier New" panose="02070309020205020404" pitchFamily="49" charset="0"/>
-                <a:cs typeface="Courier New" panose="02070309020205020404" pitchFamily="49" charset="0"/>
-              </a:rPr>
-              <a:t>-out?      </a:t>
-            </a:r>
-            <a:r>
-              <a:rPr lang="de-CH" sz="900" dirty="0" err="1">
+              <a:rPr lang="en-US" sz="900" noProof="0" dirty="0">
+                <a:highlight>
+                  <a:srgbClr val="FFFF00"/>
+                </a:highlight>
+                <a:latin typeface="Courier New" panose="02070309020205020404" pitchFamily="49" charset="0"/>
+                <a:cs typeface="Courier New" panose="02070309020205020404" pitchFamily="49" charset="0"/>
+              </a:rPr>
+              <a:t>       |        +-- adj-rib-out?      </a:t>
+            </a:r>
+            <a:r>
+              <a:rPr lang="en-US" sz="900" noProof="0" dirty="0" err="1">
                 <a:highlight>
                   <a:srgbClr val="FFFF00"/>
                 </a:highlight>
@@ -12419,7 +11576,7 @@
               </a:rPr>
               <a:t>boolean</a:t>
             </a:r>
-            <a:endParaRPr lang="de-CH" sz="900" dirty="0">
+            <a:endParaRPr lang="en-US" sz="900" noProof="0" dirty="0">
               <a:highlight>
                 <a:srgbClr val="FFFF00"/>
               </a:highlight>
@@ -12429,37 +11586,17 @@
           </a:p>
           <a:p>
             <a:r>
-              <a:rPr lang="de-CH" sz="900" dirty="0">
-                <a:highlight>
-                  <a:srgbClr val="FFFF00"/>
-                </a:highlight>
-                <a:latin typeface="Courier New" panose="02070309020205020404" pitchFamily="49" charset="0"/>
-                <a:cs typeface="Courier New" panose="02070309020205020404" pitchFamily="49" charset="0"/>
-              </a:rPr>
-              <a:t>       |        +-- </a:t>
-            </a:r>
-            <a:r>
-              <a:rPr lang="de-CH" sz="900" dirty="0" err="1">
-                <a:highlight>
-                  <a:srgbClr val="FFFF00"/>
-                </a:highlight>
-                <a:latin typeface="Courier New" panose="02070309020205020404" pitchFamily="49" charset="0"/>
-                <a:cs typeface="Courier New" panose="02070309020205020404" pitchFamily="49" charset="0"/>
-              </a:rPr>
-              <a:t>filtered</a:t>
-            </a:r>
-            <a:r>
-              <a:rPr lang="de-CH" sz="900" dirty="0">
-                <a:highlight>
-                  <a:srgbClr val="FFFF00"/>
-                </a:highlight>
-                <a:latin typeface="Courier New" panose="02070309020205020404" pitchFamily="49" charset="0"/>
-                <a:cs typeface="Courier New" panose="02070309020205020404" pitchFamily="49" charset="0"/>
-              </a:rPr>
-              <a:t>?         </a:t>
-            </a:r>
-            <a:r>
-              <a:rPr lang="de-CH" sz="900" dirty="0" err="1">
+              <a:rPr lang="en-US" sz="900" noProof="0" dirty="0">
+                <a:highlight>
+                  <a:srgbClr val="FFFF00"/>
+                </a:highlight>
+                <a:latin typeface="Courier New" panose="02070309020205020404" pitchFamily="49" charset="0"/>
+                <a:cs typeface="Courier New" panose="02070309020205020404" pitchFamily="49" charset="0"/>
+              </a:rPr>
+              <a:t>       |        +-- filtered?         </a:t>
+            </a:r>
+            <a:r>
+              <a:rPr lang="en-US" sz="900" noProof="0" dirty="0" err="1">
                 <a:highlight>
                   <a:srgbClr val="FFFF00"/>
                 </a:highlight>
@@ -12468,7 +11605,7 @@
               </a:rPr>
               <a:t>boolean</a:t>
             </a:r>
-            <a:endParaRPr lang="de-CH" sz="900" dirty="0">
+            <a:endParaRPr lang="en-US" sz="900" noProof="0" dirty="0">
               <a:highlight>
                 <a:srgbClr val="FFFF00"/>
               </a:highlight>
@@ -17615,7 +16752,7 @@
             </a:r>
             <a:r>
               <a:rPr lang="de-CH" sz="2100" dirty="0" err="1"/>
-              <a:t>included</a:t>
+              <a:t>including</a:t>
             </a:r>
             <a:r>
               <a:rPr lang="de-CH" sz="2100" dirty="0"/>
@@ -17623,7 +16760,7 @@
             </a:r>
             <a:r>
               <a:rPr lang="de-CH" sz="2100" dirty="0" err="1"/>
-              <a:t>stats</a:t>
+              <a:t>statistics</a:t>
             </a:r>
             <a:r>
               <a:rPr lang="de-CH" sz="2100" dirty="0"/>

</xml_diff>